<commit_message>
fix(course): sync approved lesson content and all 16 slide decks
</commit_message>
<xml_diff>
--- a/lessons/lesson-03/slides.pptx
+++ b/lessons/lesson-03/slides.pptx
@@ -2,33 +2,33 @@
 <file path=ppt/presentation.xml><?xml version="1.0" encoding="utf-8"?>
 <p:presentation xmlns:p="http://schemas.openxmlformats.org/presentationml/2006/main">
   <p:sldMasterIdLst>
-    <p:sldMasterId xmlns:r="http://schemas.openxmlformats.org/officeDocument/2006/relationships" id="2147483648" r:id="R0dbe0354d5d649cd"/>
+    <p:sldMasterId xmlns:r="http://schemas.openxmlformats.org/officeDocument/2006/relationships" id="2147483648" r:id="Rf996d5e4b60845dd"/>
   </p:sldMasterIdLst>
   <p:notesMasterIdLst>
-    <p:notesMasterId xmlns:r="http://schemas.openxmlformats.org/officeDocument/2006/relationships" r:id="R19671e1af20244b0"/>
+    <p:notesMasterId xmlns:r="http://schemas.openxmlformats.org/officeDocument/2006/relationships" r:id="Re1da9e76cb654fd2"/>
   </p:notesMasterIdLst>
   <p:sldIdLst>
-    <p:sldId xmlns:r="http://schemas.openxmlformats.org/officeDocument/2006/relationships" id="256" r:id="Rfd4f437e7fd44323"/>
-    <p:sldId xmlns:r="http://schemas.openxmlformats.org/officeDocument/2006/relationships" id="257" r:id="Rcaefba14ea15488f"/>
-    <p:sldId xmlns:r="http://schemas.openxmlformats.org/officeDocument/2006/relationships" id="258" r:id="Rd9776020d0754a3a"/>
-    <p:sldId xmlns:r="http://schemas.openxmlformats.org/officeDocument/2006/relationships" id="259" r:id="R0c0819f55314483d"/>
-    <p:sldId xmlns:r="http://schemas.openxmlformats.org/officeDocument/2006/relationships" id="260" r:id="Rdc85c76c09654515"/>
-    <p:sldId xmlns:r="http://schemas.openxmlformats.org/officeDocument/2006/relationships" id="261" r:id="Rf4027466449a4450"/>
-    <p:sldId xmlns:r="http://schemas.openxmlformats.org/officeDocument/2006/relationships" id="262" r:id="Rff5dac17b5eb4a34"/>
-    <p:sldId xmlns:r="http://schemas.openxmlformats.org/officeDocument/2006/relationships" id="263" r:id="R34f53a3331904e96"/>
-    <p:sldId xmlns:r="http://schemas.openxmlformats.org/officeDocument/2006/relationships" id="264" r:id="Rd817d782c6804ea0"/>
-    <p:sldId xmlns:r="http://schemas.openxmlformats.org/officeDocument/2006/relationships" id="265" r:id="R826bb19519494208"/>
-    <p:sldId xmlns:r="http://schemas.openxmlformats.org/officeDocument/2006/relationships" id="266" r:id="Ra857ad8363e64774"/>
-    <p:sldId xmlns:r="http://schemas.openxmlformats.org/officeDocument/2006/relationships" id="267" r:id="R30c3fe83b4304974"/>
-    <p:sldId xmlns:r="http://schemas.openxmlformats.org/officeDocument/2006/relationships" id="268" r:id="R0e382aeddcf34f9a"/>
-    <p:sldId xmlns:r="http://schemas.openxmlformats.org/officeDocument/2006/relationships" id="269" r:id="R5f2e95c587dd49c1"/>
-    <p:sldId xmlns:r="http://schemas.openxmlformats.org/officeDocument/2006/relationships" id="270" r:id="Rb471545e5fd342c2"/>
-    <p:sldId xmlns:r="http://schemas.openxmlformats.org/officeDocument/2006/relationships" id="271" r:id="R1fee208780c04341"/>
-    <p:sldId xmlns:r="http://schemas.openxmlformats.org/officeDocument/2006/relationships" id="272" r:id="R5c615d84ecc24f50"/>
-    <p:sldId xmlns:r="http://schemas.openxmlformats.org/officeDocument/2006/relationships" id="273" r:id="R77c6e498d0be47eb"/>
-    <p:sldId xmlns:r="http://schemas.openxmlformats.org/officeDocument/2006/relationships" id="274" r:id="R2cebd35906f74926"/>
-    <p:sldId xmlns:r="http://schemas.openxmlformats.org/officeDocument/2006/relationships" id="275" r:id="R2f903a34ff1f477b"/>
-    <p:sldId xmlns:r="http://schemas.openxmlformats.org/officeDocument/2006/relationships" id="276" r:id="R155e4ae3398b420b"/>
+    <p:sldId xmlns:r="http://schemas.openxmlformats.org/officeDocument/2006/relationships" id="256" r:id="Rffcb86cc1d484d31"/>
+    <p:sldId xmlns:r="http://schemas.openxmlformats.org/officeDocument/2006/relationships" id="257" r:id="R8edbcf1e1af94b39"/>
+    <p:sldId xmlns:r="http://schemas.openxmlformats.org/officeDocument/2006/relationships" id="258" r:id="R47ac3c346ee84bb9"/>
+    <p:sldId xmlns:r="http://schemas.openxmlformats.org/officeDocument/2006/relationships" id="259" r:id="R598a800a7075452c"/>
+    <p:sldId xmlns:r="http://schemas.openxmlformats.org/officeDocument/2006/relationships" id="260" r:id="Rdb3cb112b75f4bcc"/>
+    <p:sldId xmlns:r="http://schemas.openxmlformats.org/officeDocument/2006/relationships" id="261" r:id="R538ce59a13654321"/>
+    <p:sldId xmlns:r="http://schemas.openxmlformats.org/officeDocument/2006/relationships" id="262" r:id="R3aad7d8841fa4506"/>
+    <p:sldId xmlns:r="http://schemas.openxmlformats.org/officeDocument/2006/relationships" id="263" r:id="R1b5c38cca02c4984"/>
+    <p:sldId xmlns:r="http://schemas.openxmlformats.org/officeDocument/2006/relationships" id="264" r:id="Rfa798eef3b6e4f98"/>
+    <p:sldId xmlns:r="http://schemas.openxmlformats.org/officeDocument/2006/relationships" id="265" r:id="R1cb3723cd982459e"/>
+    <p:sldId xmlns:r="http://schemas.openxmlformats.org/officeDocument/2006/relationships" id="266" r:id="Reafdd44243d047ca"/>
+    <p:sldId xmlns:r="http://schemas.openxmlformats.org/officeDocument/2006/relationships" id="267" r:id="R6089dca0dcb648fa"/>
+    <p:sldId xmlns:r="http://schemas.openxmlformats.org/officeDocument/2006/relationships" id="268" r:id="R3e94917428854622"/>
+    <p:sldId xmlns:r="http://schemas.openxmlformats.org/officeDocument/2006/relationships" id="269" r:id="R6236e1cdb3b64c64"/>
+    <p:sldId xmlns:r="http://schemas.openxmlformats.org/officeDocument/2006/relationships" id="270" r:id="Raa6643bc2fea4139"/>
+    <p:sldId xmlns:r="http://schemas.openxmlformats.org/officeDocument/2006/relationships" id="271" r:id="R64a3a7e7265644ee"/>
+    <p:sldId xmlns:r="http://schemas.openxmlformats.org/officeDocument/2006/relationships" id="272" r:id="Rd390abbf45164213"/>
+    <p:sldId xmlns:r="http://schemas.openxmlformats.org/officeDocument/2006/relationships" id="273" r:id="R86b5b83877d941f2"/>
+    <p:sldId xmlns:r="http://schemas.openxmlformats.org/officeDocument/2006/relationships" id="274" r:id="R0df8a5918eea4449"/>
+    <p:sldId xmlns:r="http://schemas.openxmlformats.org/officeDocument/2006/relationships" id="275" r:id="R918fd2fef8ee406a"/>
+    <p:sldId xmlns:r="http://schemas.openxmlformats.org/officeDocument/2006/relationships" id="276" r:id="Rd064d11e84fe4777"/>
   </p:sldIdLst>
   <p:sldSz cx="12192000" cy="6858000"/>
   <p:notesSz cx="6858000" cy="9144000"/>
@@ -408,7 +408,92 @@
           <a:lstStyle xmlns:a="http://schemas.openxmlformats.org/drawingml/2006/main"/>
           <a:p xmlns:a="http://schemas.openxmlformats.org/drawingml/2006/main">
             <a:r>
-              <a:t>页面标题：第3讲 文献检索与证据角色</a:t>
+              <a:t>页面：P01 第3讲 文献检索与证据角色</a:t>
+            </a:r>
+          </a:p>
+          <a:p xmlns:a="http://schemas.openxmlformats.org/drawingml/2006/main">
+            <a:r>
+              <a:t/>
+            </a:r>
+          </a:p>
+          <a:p xmlns:a="http://schemas.openxmlformats.org/drawingml/2006/main">
+            <a:r>
+              <a:t>讲义位置：本课讲义；见逐页母稿映射表</a:t>
+            </a:r>
+          </a:p>
+          <a:p xmlns:a="http://schemas.openxmlformats.org/drawingml/2006/main">
+            <a:r>
+              <a:t/>
+            </a:r>
+          </a:p>
+          <a:p xmlns:a="http://schemas.openxmlformats.org/drawingml/2006/main">
+            <a:r>
+              <a:t>屏显核对：</a:t>
+            </a:r>
+          </a:p>
+          <a:p xmlns:a="http://schemas.openxmlformats.org/drawingml/2006/main">
+            <a:r>
+              <a:t>第3讲 文献检索与证据角色</a:t>
+            </a:r>
+          </a:p>
+          <a:p xmlns:a="http://schemas.openxmlformats.org/drawingml/2006/main">
+            <a:r>
+              <a:t/>
+            </a:r>
+          </a:p>
+          <a:p xmlns:a="http://schemas.openxmlformats.org/drawingml/2006/main">
+            <a:r>
+              <a:t>教师讲述：</a:t>
+            </a:r>
+          </a:p>
+          <a:p xmlns:a="http://schemas.openxmlformats.org/drawingml/2006/main">
+            <a:r>
+              <a:t>封面只完成课次与主题识别。进入 P02 后再提出方法问题：当 AI 已经能生成带引用的报告时，研究者怎样把检索过程变成可复盘的方法，并判断每条材料的证据角色。</a:t>
+            </a:r>
+          </a:p>
+          <a:p xmlns:a="http://schemas.openxmlformats.org/drawingml/2006/main">
+            <a:r>
+              <a:t/>
+            </a:r>
+          </a:p>
+          <a:p xmlns:a="http://schemas.openxmlformats.org/drawingml/2006/main">
+            <a:r>
+              <a:t>学生动作：</a:t>
+            </a:r>
+          </a:p>
+          <a:p xmlns:a="http://schemas.openxmlformats.org/drawingml/2006/main">
+            <a:r>
+              <a:t>不展开课程行政信息，直接进入下一页回扣。</a:t>
+            </a:r>
+          </a:p>
+          <a:p xmlns:a="http://schemas.openxmlformats.org/drawingml/2006/main">
+            <a:r>
+              <a:t/>
+            </a:r>
+          </a:p>
+          <a:p xmlns:a="http://schemas.openxmlformats.org/drawingml/2006/main">
+            <a:r>
+              <a:t>来源与边界：</a:t>
+            </a:r>
+          </a:p>
+          <a:p xmlns:a="http://schemas.openxmlformats.org/drawingml/2006/main">
+            <a:r>
+              <a:t>课程定位以 [syllabus.md](../../course/syllabus.md) 与 [备课规划.md](../备课规划.md) 第 3 课段为准。</a:t>
+            </a:r>
+          </a:p>
+          <a:p xmlns:a="http://schemas.openxmlformats.org/drawingml/2006/main">
+            <a:r>
+              <a:t/>
+            </a:r>
+          </a:p>
+          <a:p xmlns:a="http://schemas.openxmlformats.org/drawingml/2006/main">
+            <a:r>
+              <a:t>---</a:t>
+            </a:r>
+          </a:p>
+          <a:p xmlns:a="http://schemas.openxmlformats.org/drawingml/2006/main">
+            <a:r>
+              <a:t/>
             </a:r>
           </a:p>
           <a:p xmlns:a="http://schemas.openxmlformats.org/drawingml/2006/main">
@@ -418,7 +503,17 @@
           </a:p>
           <a:p xmlns:a="http://schemas.openxmlformats.org/drawingml/2006/main">
             <a:r>
-              <a:t>- 本页仅使用课程内部规则与教学材料。</a:t>
+              <a:t/>
+            </a:r>
+          </a:p>
+          <a:p xmlns:a="http://schemas.openxmlformats.org/drawingml/2006/main">
+            <a:r>
+              <a:t>- 本课 handout.md 与 slides.md</a:t>
+            </a:r>
+          </a:p>
+          <a:p xmlns:a="http://schemas.openxmlformats.org/drawingml/2006/main">
+            <a:r>
+              <a:t/>
             </a:r>
           </a:p>
           <a:p xmlns:a="http://schemas.openxmlformats.org/drawingml/2006/main">
@@ -493,7 +588,132 @@
           <a:lstStyle xmlns:a="http://schemas.openxmlformats.org/drawingml/2006/main"/>
           <a:p xmlns:a="http://schemas.openxmlformats.org/drawingml/2006/main">
             <a:r>
-              <a:t>页面标题：证据角色：补充证据与对比证据</a:t>
+              <a:t>页面：P10 证据角色：补充证据与对比证据</a:t>
+            </a:r>
+          </a:p>
+          <a:p xmlns:a="http://schemas.openxmlformats.org/drawingml/2006/main">
+            <a:r>
+              <a:t/>
+            </a:r>
+          </a:p>
+          <a:p xmlns:a="http://schemas.openxmlformats.org/drawingml/2006/main">
+            <a:r>
+              <a:t>讲义位置：本课讲义；见逐页母稿映射表</a:t>
+            </a:r>
+          </a:p>
+          <a:p xmlns:a="http://schemas.openxmlformats.org/drawingml/2006/main">
+            <a:r>
+              <a:t/>
+            </a:r>
+          </a:p>
+          <a:p xmlns:a="http://schemas.openxmlformats.org/drawingml/2006/main">
+            <a:r>
+              <a:t>屏显核对：</a:t>
+            </a:r>
+          </a:p>
+          <a:p xmlns:a="http://schemas.openxmlformats.org/drawingml/2006/main">
+            <a:r>
+              <a:t>补充证据</a:t>
+            </a:r>
+          </a:p>
+          <a:p xmlns:a="http://schemas.openxmlformats.org/drawingml/2006/main">
+            <a:r>
+              <a:t>- 从不同来源、测量或路径补充支持同一主张</a:t>
+            </a:r>
+          </a:p>
+          <a:p xmlns:a="http://schemas.openxmlformats.org/drawingml/2006/main">
+            <a:r>
+              <a:t>- 提供独立性</a:t>
+            </a:r>
+          </a:p>
+          <a:p xmlns:a="http://schemas.openxmlformats.org/drawingml/2006/main">
+            <a:r>
+              <a:t/>
+            </a:r>
+          </a:p>
+          <a:p xmlns:a="http://schemas.openxmlformats.org/drawingml/2006/main">
+            <a:r>
+              <a:t>对比证据</a:t>
+            </a:r>
+          </a:p>
+          <a:p xmlns:a="http://schemas.openxmlformats.org/drawingml/2006/main">
+            <a:r>
+              <a:t>- 提供替代解释、竞争假设或反例</a:t>
+            </a:r>
+          </a:p>
+          <a:p xmlns:a="http://schemas.openxmlformats.org/drawingml/2006/main">
+            <a:r>
+              <a:t>- 暴露当前解释的边界</a:t>
+            </a:r>
+          </a:p>
+          <a:p xmlns:a="http://schemas.openxmlformats.org/drawingml/2006/main">
+            <a:r>
+              <a:t/>
+            </a:r>
+          </a:p>
+          <a:p xmlns:a="http://schemas.openxmlformats.org/drawingml/2006/main">
+            <a:r>
+              <a:t>&gt; 独立 ≠ 两个不同网页；冲突证据必须呈现。</a:t>
+            </a:r>
+          </a:p>
+          <a:p xmlns:a="http://schemas.openxmlformats.org/drawingml/2006/main">
+            <a:r>
+              <a:t/>
+            </a:r>
+          </a:p>
+          <a:p xmlns:a="http://schemas.openxmlformats.org/drawingml/2006/main">
+            <a:r>
+              <a:t>教师讲述：</a:t>
+            </a:r>
+          </a:p>
+          <a:p xmlns:a="http://schemas.openxmlformats.org/drawingml/2006/main">
+            <a:r>
+              <a:t>"独立"不简单等于两个不同网页。两篇互相转载的文章不是两项独立证据；同一代码路径运行两次也未必构成独立验证。独立性来自来源、测量、重复实验、对照、消融或分析路径的实质差异。冲突证据必须呈现，不能只保留支持项。</a:t>
+            </a:r>
+          </a:p>
+          <a:p xmlns:a="http://schemas.openxmlformats.org/drawingml/2006/main">
+            <a:r>
+              <a:t/>
+            </a:r>
+          </a:p>
+          <a:p xmlns:a="http://schemas.openxmlformats.org/drawingml/2006/main">
+            <a:r>
+              <a:t>学生动作：</a:t>
+            </a:r>
+          </a:p>
+          <a:p xmlns:a="http://schemas.openxmlformats.org/drawingml/2006/main">
+            <a:r>
+              <a:t>请学生举一个"看似独立其实不独立"的例子。</a:t>
+            </a:r>
+          </a:p>
+          <a:p xmlns:a="http://schemas.openxmlformats.org/drawingml/2006/main">
+            <a:r>
+              <a:t/>
+            </a:r>
+          </a:p>
+          <a:p xmlns:a="http://schemas.openxmlformats.org/drawingml/2006/main">
+            <a:r>
+              <a:t>来源与边界：</a:t>
+            </a:r>
+          </a:p>
+          <a:p xmlns:a="http://schemas.openxmlformats.org/drawingml/2006/main">
+            <a:r>
+              <a:t>讲义 §三；[AGENTS.md](../../AGENTS.md) "稳定结论原则上需要两项相互独立的证据"。</a:t>
+            </a:r>
+          </a:p>
+          <a:p xmlns:a="http://schemas.openxmlformats.org/drawingml/2006/main">
+            <a:r>
+              <a:t/>
+            </a:r>
+          </a:p>
+          <a:p xmlns:a="http://schemas.openxmlformats.org/drawingml/2006/main">
+            <a:r>
+              <a:t>---</a:t>
+            </a:r>
+          </a:p>
+          <a:p xmlns:a="http://schemas.openxmlformats.org/drawingml/2006/main">
+            <a:r>
+              <a:t/>
             </a:r>
           </a:p>
           <a:p xmlns:a="http://schemas.openxmlformats.org/drawingml/2006/main">
@@ -503,7 +723,17 @@
           </a:p>
           <a:p xmlns:a="http://schemas.openxmlformats.org/drawingml/2006/main">
             <a:r>
-              <a:t>- 本页仅使用课程内部规则与教学材料。</a:t>
+              <a:t/>
+            </a:r>
+          </a:p>
+          <a:p xmlns:a="http://schemas.openxmlformats.org/drawingml/2006/main">
+            <a:r>
+              <a:t>- 本课 handout.md 与 slides.md</a:t>
+            </a:r>
+          </a:p>
+          <a:p xmlns:a="http://schemas.openxmlformats.org/drawingml/2006/main">
+            <a:r>
+              <a:t/>
             </a:r>
           </a:p>
           <a:p xmlns:a="http://schemas.openxmlformats.org/drawingml/2006/main">
@@ -578,7 +808,132 @@
           <a:lstStyle xmlns:a="http://schemas.openxmlformats.org/drawingml/2006/main"/>
           <a:p xmlns:a="http://schemas.openxmlformats.org/drawingml/2006/main">
             <a:r>
-              <a:t>页面标题：证据角色：探索线索（AI 输出归位）</a:t>
+              <a:t>页面：P11 证据角色：探索线索（AI 输出归位）</a:t>
+            </a:r>
+          </a:p>
+          <a:p xmlns:a="http://schemas.openxmlformats.org/drawingml/2006/main">
+            <a:r>
+              <a:t/>
+            </a:r>
+          </a:p>
+          <a:p xmlns:a="http://schemas.openxmlformats.org/drawingml/2006/main">
+            <a:r>
+              <a:t>讲义位置：本课讲义；见逐页母稿映射表</a:t>
+            </a:r>
+          </a:p>
+          <a:p xmlns:a="http://schemas.openxmlformats.org/drawingml/2006/main">
+            <a:r>
+              <a:t/>
+            </a:r>
+          </a:p>
+          <a:p xmlns:a="http://schemas.openxmlformats.org/drawingml/2006/main">
+            <a:r>
+              <a:t>屏显核对：</a:t>
+            </a:r>
+          </a:p>
+          <a:p xmlns:a="http://schemas.openxmlformats.org/drawingml/2006/main">
+            <a:r>
+              <a:t>探索线索</a:t>
+            </a:r>
+          </a:p>
+          <a:p xmlns:a="http://schemas.openxmlformats.org/drawingml/2006/main">
+            <a:r>
+              <a:t>- 帮助发现关键词、问题或失败模式</a:t>
+            </a:r>
+          </a:p>
+          <a:p xmlns:a="http://schemas.openxmlformats.org/drawingml/2006/main">
+            <a:r>
+              <a:t>- 即使已核验，也可能不能直接回答当前问题</a:t>
+            </a:r>
+          </a:p>
+          <a:p xmlns:a="http://schemas.openxmlformats.org/drawingml/2006/main">
+            <a:r>
+              <a:t/>
+            </a:r>
+          </a:p>
+          <a:p xmlns:a="http://schemas.openxmlformats.org/drawingml/2006/main">
+            <a:r>
+              <a:t>AI 检索结果默认归此类</a:t>
+            </a:r>
+          </a:p>
+          <a:p xmlns:a="http://schemas.openxmlformats.org/drawingml/2006/main">
+            <a:r>
+              <a:t/>
+            </a:r>
+          </a:p>
+          <a:p xmlns:a="http://schemas.openxmlformats.org/drawingml/2006/main">
+            <a:r>
+              <a:t>角色 ≠ 核验状态 ≠ 筛选决定</a:t>
+            </a:r>
+          </a:p>
+          <a:p xmlns:a="http://schemas.openxmlformats.org/drawingml/2006/main">
+            <a:r>
+              <a:t/>
+            </a:r>
+          </a:p>
+          <a:p xmlns:a="http://schemas.openxmlformats.org/drawingml/2006/main">
+            <a:r>
+              <a:t>&gt; 一篇真实且已核验的论文，对当前问题仍可能只是探索线索。</a:t>
+            </a:r>
+          </a:p>
+          <a:p xmlns:a="http://schemas.openxmlformats.org/drawingml/2006/main">
+            <a:r>
+              <a:t/>
+            </a:r>
+          </a:p>
+          <a:p xmlns:a="http://schemas.openxmlformats.org/drawingml/2006/main">
+            <a:r>
+              <a:t>教师讲述：</a:t>
+            </a:r>
+          </a:p>
+          <a:p xmlns:a="http://schemas.openxmlformats.org/drawingml/2006/main">
+            <a:r>
+              <a:t>回扣第 1 课：AI 输出成为证据或结论前必须回到原文。本课再拆开三个字段：预期角色回答“可能做什么”，核验状态回答“核到哪里”，筛选决定回答“是否保留”。下一页讲入口核验。</a:t>
+            </a:r>
+          </a:p>
+          <a:p xmlns:a="http://schemas.openxmlformats.org/drawingml/2006/main">
+            <a:r>
+              <a:t/>
+            </a:r>
+          </a:p>
+          <a:p xmlns:a="http://schemas.openxmlformats.org/drawingml/2006/main">
+            <a:r>
+              <a:t>学生动作：</a:t>
+            </a:r>
+          </a:p>
+          <a:p xmlns:a="http://schemas.openxmlformats.org/drawingml/2006/main">
+            <a:r>
+              <a:t>让学生指出：你之前把 AI 给出的哪条引文当成了主证据？现在应该归到哪类？</a:t>
+            </a:r>
+          </a:p>
+          <a:p xmlns:a="http://schemas.openxmlformats.org/drawingml/2006/main">
+            <a:r>
+              <a:t/>
+            </a:r>
+          </a:p>
+          <a:p xmlns:a="http://schemas.openxmlformats.org/drawingml/2006/main">
+            <a:r>
+              <a:t>来源与边界：</a:t>
+            </a:r>
+          </a:p>
+          <a:p xmlns:a="http://schemas.openxmlformats.org/drawingml/2006/main">
+            <a:r>
+              <a:t>第 1 课 handout §2.4 外部输入摄取；[reading-list.md](../../course/reading-list.md) AI 辅助阅读协议。</a:t>
+            </a:r>
+          </a:p>
+          <a:p xmlns:a="http://schemas.openxmlformats.org/drawingml/2006/main">
+            <a:r>
+              <a:t/>
+            </a:r>
+          </a:p>
+          <a:p xmlns:a="http://schemas.openxmlformats.org/drawingml/2006/main">
+            <a:r>
+              <a:t>---</a:t>
+            </a:r>
+          </a:p>
+          <a:p xmlns:a="http://schemas.openxmlformats.org/drawingml/2006/main">
+            <a:r>
+              <a:t/>
             </a:r>
           </a:p>
           <a:p xmlns:a="http://schemas.openxmlformats.org/drawingml/2006/main">
@@ -588,7 +943,17 @@
           </a:p>
           <a:p xmlns:a="http://schemas.openxmlformats.org/drawingml/2006/main">
             <a:r>
-              <a:t>- 本页仅使用课程内部规则与教学材料。</a:t>
+              <a:t/>
+            </a:r>
+          </a:p>
+          <a:p xmlns:a="http://schemas.openxmlformats.org/drawingml/2006/main">
+            <a:r>
+              <a:t>- 本课 handout.md 与 slides.md</a:t>
+            </a:r>
+          </a:p>
+          <a:p xmlns:a="http://schemas.openxmlformats.org/drawingml/2006/main">
+            <a:r>
+              <a:t/>
             </a:r>
           </a:p>
           <a:p xmlns:a="http://schemas.openxmlformats.org/drawingml/2006/main">
@@ -663,7 +1028,137 @@
           <a:lstStyle xmlns:a="http://schemas.openxmlformats.org/drawingml/2006/main"/>
           <a:p xmlns:a="http://schemas.openxmlformats.org/drawingml/2006/main">
             <a:r>
-              <a:t>页面标题：入口核验：身份 + 一条拟用主张</a:t>
+              <a:t>页面：P12 入口核验：身份 + 一条拟用主张</a:t>
+            </a:r>
+          </a:p>
+          <a:p xmlns:a="http://schemas.openxmlformats.org/drawingml/2006/main">
+            <a:r>
+              <a:t/>
+            </a:r>
+          </a:p>
+          <a:p xmlns:a="http://schemas.openxmlformats.org/drawingml/2006/main">
+            <a:r>
+              <a:t>讲义位置：本课讲义；见逐页母稿映射表</a:t>
+            </a:r>
+          </a:p>
+          <a:p xmlns:a="http://schemas.openxmlformats.org/drawingml/2006/main">
+            <a:r>
+              <a:t/>
+            </a:r>
+          </a:p>
+          <a:p xmlns:a="http://schemas.openxmlformats.org/drawingml/2006/main">
+            <a:r>
+              <a:t>屏显核对：</a:t>
+            </a:r>
+          </a:p>
+          <a:p xmlns:a="http://schemas.openxmlformats.org/drawingml/2006/main">
+            <a:r>
+              <a:t>身份层：题名｜作者｜年份｜刊会｜DOI/稳定标识</a:t>
+            </a:r>
+          </a:p>
+          <a:p xmlns:a="http://schemas.openxmlformats.org/drawingml/2006/main">
+            <a:r>
+              <a:t/>
+            </a:r>
+          </a:p>
+          <a:p xmlns:a="http://schemas.openxmlformats.org/drawingml/2006/main">
+            <a:r>
+              <a:t>拟用主张层：</a:t>
+            </a:r>
+          </a:p>
+          <a:p xmlns:a="http://schemas.openxmlformats.org/drawingml/2006/main">
+            <a:r>
+              <a:t>1. 先写准备用它支持什么；</a:t>
+            </a:r>
+          </a:p>
+          <a:p xmlns:a="http://schemas.openxmlformats.org/drawingml/2006/main">
+            <a:r>
+              <a:t>2. 回到至少一个原文位置；</a:t>
+            </a:r>
+          </a:p>
+          <a:p xmlns:a="http://schemas.openxmlformats.org/drawingml/2006/main">
+            <a:r>
+              <a:t>3. 核对任务、设置、措辞强度与必要限定。</a:t>
+            </a:r>
+          </a:p>
+          <a:p xmlns:a="http://schemas.openxmlformats.org/drawingml/2006/main">
+            <a:r>
+              <a:t/>
+            </a:r>
+          </a:p>
+          <a:p xmlns:a="http://schemas.openxmlformats.org/drawingml/2006/main">
+            <a:r>
+              <a:t>只完成身份层 → `pending`｜默认探索线索</a:t>
+            </a:r>
+          </a:p>
+          <a:p xmlns:a="http://schemas.openxmlformats.org/drawingml/2006/main">
+            <a:r>
+              <a:t/>
+            </a:r>
+          </a:p>
+          <a:p xmlns:a="http://schemas.openxmlformats.org/drawingml/2006/main">
+            <a:r>
+              <a:t>第 4 课移交：多条主张、位置、指标、对照、样本、贡献与局限</a:t>
+            </a:r>
+          </a:p>
+          <a:p xmlns:a="http://schemas.openxmlformats.org/drawingml/2006/main">
+            <a:r>
+              <a:t/>
+            </a:r>
+          </a:p>
+          <a:p xmlns:a="http://schemas.openxmlformats.org/drawingml/2006/main">
+            <a:r>
+              <a:t>教师讲述：</a:t>
+            </a:r>
+          </a:p>
+          <a:p xmlns:a="http://schemas.openxmlformats.org/drawingml/2006/main">
+            <a:r>
+              <a:t>本课不是只查 DOI，也不是把完整精读塞进一页。入口核验必须包含身份和一条拟用主张；多主张结构、指标和局限由第 4 课深化。DOI 缺失、网络超时或限流只产生失败记录和 `pending`，不能自动写成 `rejected`。</a:t>
+            </a:r>
+          </a:p>
+          <a:p xmlns:a="http://schemas.openxmlformats.org/drawingml/2006/main">
+            <a:r>
+              <a:t/>
+            </a:r>
+          </a:p>
+          <a:p xmlns:a="http://schemas.openxmlformats.org/drawingml/2006/main">
+            <a:r>
+              <a:t>学生动作：</a:t>
+            </a:r>
+          </a:p>
+          <a:p xmlns:a="http://schemas.openxmlformats.org/drawingml/2006/main">
+            <a:r>
+              <a:t>无。直接进入演示。</a:t>
+            </a:r>
+          </a:p>
+          <a:p xmlns:a="http://schemas.openxmlformats.org/drawingml/2006/main">
+            <a:r>
+              <a:t/>
+            </a:r>
+          </a:p>
+          <a:p xmlns:a="http://schemas.openxmlformats.org/drawingml/2006/main">
+            <a:r>
+              <a:t>来源与边界：</a:t>
+            </a:r>
+          </a:p>
+          <a:p xmlns:a="http://schemas.openxmlformats.org/drawingml/2006/main">
+            <a:r>
+              <a:t>讲义 §四·2 入口核验与精读移交；AI 输出不构成证据（[AGENTS.md](../../AGENTS.md)）。</a:t>
+            </a:r>
+          </a:p>
+          <a:p xmlns:a="http://schemas.openxmlformats.org/drawingml/2006/main">
+            <a:r>
+              <a:t/>
+            </a:r>
+          </a:p>
+          <a:p xmlns:a="http://schemas.openxmlformats.org/drawingml/2006/main">
+            <a:r>
+              <a:t>---</a:t>
+            </a:r>
+          </a:p>
+          <a:p xmlns:a="http://schemas.openxmlformats.org/drawingml/2006/main">
+            <a:r>
+              <a:t/>
             </a:r>
           </a:p>
           <a:p xmlns:a="http://schemas.openxmlformats.org/drawingml/2006/main">
@@ -673,7 +1168,17 @@
           </a:p>
           <a:p xmlns:a="http://schemas.openxmlformats.org/drawingml/2006/main">
             <a:r>
-              <a:t>- 本页仅使用课程内部规则与教学材料。</a:t>
+              <a:t/>
+            </a:r>
+          </a:p>
+          <a:p xmlns:a="http://schemas.openxmlformats.org/drawingml/2006/main">
+            <a:r>
+              <a:t>- 本课 handout.md 与 slides.md</a:t>
+            </a:r>
+          </a:p>
+          <a:p xmlns:a="http://schemas.openxmlformats.org/drawingml/2006/main">
+            <a:r>
+              <a:t/>
             </a:r>
           </a:p>
           <a:p xmlns:a="http://schemas.openxmlformats.org/drawingml/2006/main">
@@ -748,7 +1253,142 @@
           <a:lstStyle xmlns:a="http://schemas.openxmlformats.org/drawingml/2006/main"/>
           <a:p xmlns:a="http://schemas.openxmlformats.org/drawingml/2006/main">
             <a:r>
-              <a:t>页面标题：演示：检索记录定位真实论文</a:t>
+              <a:t>页面：P13 演示：检索记录定位真实论文</a:t>
+            </a:r>
+          </a:p>
+          <a:p xmlns:a="http://schemas.openxmlformats.org/drawingml/2006/main">
+            <a:r>
+              <a:t/>
+            </a:r>
+          </a:p>
+          <a:p xmlns:a="http://schemas.openxmlformats.org/drawingml/2006/main">
+            <a:r>
+              <a:t>讲义位置：本课讲义；见逐页母稿映射表</a:t>
+            </a:r>
+          </a:p>
+          <a:p xmlns:a="http://schemas.openxmlformats.org/drawingml/2006/main">
+            <a:r>
+              <a:t/>
+            </a:r>
+          </a:p>
+          <a:p xmlns:a="http://schemas.openxmlformats.org/drawingml/2006/main">
+            <a:r>
+              <a:t>屏显核对：</a:t>
+            </a:r>
+          </a:p>
+          <a:p xmlns:a="http://schemas.openxmlformats.org/drawingml/2006/main">
+            <a:r>
+              <a:t>Crossref 请求参数：`query.title=How to Read a Paper&amp;query.author=Keshav&amp;rows=5`</a:t>
+            </a:r>
+          </a:p>
+          <a:p xmlns:a="http://schemas.openxmlformats.org/drawingml/2006/main">
+            <a:r>
+              <a:t/>
+            </a:r>
+          </a:p>
+          <a:p xmlns:a="http://schemas.openxmlformats.org/drawingml/2006/main">
+            <a:r>
+              <a:t>Crossref 核对：</a:t>
+            </a:r>
+          </a:p>
+          <a:p xmlns:a="http://schemas.openxmlformats.org/drawingml/2006/main">
+            <a:r>
+              <a:t>- 题名：*How to Read a Paper*</a:t>
+            </a:r>
+          </a:p>
+          <a:p xmlns:a="http://schemas.openxmlformats.org/drawingml/2006/main">
+            <a:r>
+              <a:t>- 作者：S. Keshav</a:t>
+            </a:r>
+          </a:p>
+          <a:p xmlns:a="http://schemas.openxmlformats.org/drawingml/2006/main">
+            <a:r>
+              <a:t>- 刊名：*ACM SIGCOMM Computer Communication Review*</a:t>
+            </a:r>
+          </a:p>
+          <a:p xmlns:a="http://schemas.openxmlformats.org/drawingml/2006/main">
+            <a:r>
+              <a:t>- 页码：83–84</a:t>
+            </a:r>
+          </a:p>
+          <a:p xmlns:a="http://schemas.openxmlformats.org/drawingml/2006/main">
+            <a:r>
+              <a:t>- DOI：`10.1145/1273445.1273458`</a:t>
+            </a:r>
+          </a:p>
+          <a:p xmlns:a="http://schemas.openxmlformats.org/drawingml/2006/main">
+            <a:r>
+              <a:t/>
+            </a:r>
+          </a:p>
+          <a:p xmlns:a="http://schemas.openxmlformats.org/drawingml/2006/main">
+            <a:r>
+              <a:t>保留：实际请求｜来源｜日期｜原始返回</a:t>
+            </a:r>
+          </a:p>
+          <a:p xmlns:a="http://schemas.openxmlformats.org/drawingml/2006/main">
+            <a:r>
+              <a:t/>
+            </a:r>
+          </a:p>
+          <a:p xmlns:a="http://schemas.openxmlformats.org/drawingml/2006/main">
+            <a:r>
+              <a:t>教师讲述：</a:t>
+            </a:r>
+          </a:p>
+          <a:p xmlns:a="http://schemas.openxmlformats.org/drawingml/2006/main">
+            <a:r>
+              <a:t>先核对身份，不急着摘要结论。Crossref 记录证明这个 DOI 对应哪篇文章，但还不证明它支持我们需要的主张。</a:t>
+            </a:r>
+          </a:p>
+          <a:p xmlns:a="http://schemas.openxmlformats.org/drawingml/2006/main">
+            <a:r>
+              <a:t/>
+            </a:r>
+          </a:p>
+          <a:p xmlns:a="http://schemas.openxmlformats.org/drawingml/2006/main">
+            <a:r>
+              <a:t>学生动作：</a:t>
+            </a:r>
+          </a:p>
+          <a:p xmlns:a="http://schemas.openxmlformats.org/drawingml/2006/main">
+            <a:r>
+              <a:t>让学生指出：当前已核验的是文献身份，还未核验的是什么？</a:t>
+            </a:r>
+          </a:p>
+          <a:p xmlns:a="http://schemas.openxmlformats.org/drawingml/2006/main">
+            <a:r>
+              <a:t/>
+            </a:r>
+          </a:p>
+          <a:p xmlns:a="http://schemas.openxmlformats.org/drawingml/2006/main">
+            <a:r>
+              <a:t>来源与边界：</a:t>
+            </a:r>
+          </a:p>
+          <a:p xmlns:a="http://schemas.openxmlformats.org/drawingml/2006/main">
+            <a:r>
+              <a:t>- Crossref 元数据：https://api.crossref.org/works/10.1145/1273445.1273458</a:t>
+            </a:r>
+          </a:p>
+          <a:p xmlns:a="http://schemas.openxmlformats.org/drawingml/2006/main">
+            <a:r>
+              <a:t>- DOI：https://doi.org/10.1145/1273445.1273458</a:t>
+            </a:r>
+          </a:p>
+          <a:p xmlns:a="http://schemas.openxmlformats.org/drawingml/2006/main">
+            <a:r>
+              <a:t/>
+            </a:r>
+          </a:p>
+          <a:p xmlns:a="http://schemas.openxmlformats.org/drawingml/2006/main">
+            <a:r>
+              <a:t>---</a:t>
+            </a:r>
+          </a:p>
+          <a:p xmlns:a="http://schemas.openxmlformats.org/drawingml/2006/main">
+            <a:r>
+              <a:t/>
             </a:r>
           </a:p>
           <a:p xmlns:a="http://schemas.openxmlformats.org/drawingml/2006/main">
@@ -758,7 +1398,17 @@
           </a:p>
           <a:p xmlns:a="http://schemas.openxmlformats.org/drawingml/2006/main">
             <a:r>
-              <a:t>- 本页仅使用课程内部规则与教学材料。</a:t>
+              <a:t/>
+            </a:r>
+          </a:p>
+          <a:p xmlns:a="http://schemas.openxmlformats.org/drawingml/2006/main">
+            <a:r>
+              <a:t>- 本课 handout.md 与 slides.md</a:t>
+            </a:r>
+          </a:p>
+          <a:p xmlns:a="http://schemas.openxmlformats.org/drawingml/2006/main">
+            <a:r>
+              <a:t/>
             </a:r>
           </a:p>
           <a:p xmlns:a="http://schemas.openxmlformats.org/drawingml/2006/main">
@@ -833,7 +1483,132 @@
           <a:lstStyle xmlns:a="http://schemas.openxmlformats.org/drawingml/2006/main"/>
           <a:p xmlns:a="http://schemas.openxmlformats.org/drawingml/2006/main">
             <a:r>
-              <a:t>页面标题：演示：DOI → 原文第 1 页</a:t>
+              <a:t>页面：P14 演示：DOI → 原文第 1 页</a:t>
+            </a:r>
+          </a:p>
+          <a:p xmlns:a="http://schemas.openxmlformats.org/drawingml/2006/main">
+            <a:r>
+              <a:t/>
+            </a:r>
+          </a:p>
+          <a:p xmlns:a="http://schemas.openxmlformats.org/drawingml/2006/main">
+            <a:r>
+              <a:t>讲义位置：本课讲义；见逐页母稿映射表</a:t>
+            </a:r>
+          </a:p>
+          <a:p xmlns:a="http://schemas.openxmlformats.org/drawingml/2006/main">
+            <a:r>
+              <a:t/>
+            </a:r>
+          </a:p>
+          <a:p xmlns:a="http://schemas.openxmlformats.org/drawingml/2006/main">
+            <a:r>
+              <a:t>屏显核对：</a:t>
+            </a:r>
+          </a:p>
+          <a:p xmlns:a="http://schemas.openxmlformats.org/drawingml/2006/main">
+            <a:r>
+              <a:t>真实原文对象：Keshav 2007 公开 PDF，第 1 页</a:t>
+            </a:r>
+          </a:p>
+          <a:p xmlns:a="http://schemas.openxmlformats.org/drawingml/2006/main">
+            <a:r>
+              <a:t/>
+            </a:r>
+          </a:p>
+          <a:p xmlns:a="http://schemas.openxmlformats.org/drawingml/2006/main">
+            <a:r>
+              <a:t>核验三件事：</a:t>
+            </a:r>
+          </a:p>
+          <a:p xmlns:a="http://schemas.openxmlformats.org/drawingml/2006/main">
+            <a:r>
+              <a:t>1. 题名、作者与 DOI 记录一致；</a:t>
+            </a:r>
+          </a:p>
+          <a:p xmlns:a="http://schemas.openxmlformats.org/drawingml/2006/main">
+            <a:r>
+              <a:t>2. 文章提出三遍阅读法；</a:t>
+            </a:r>
+          </a:p>
+          <a:p xmlns:a="http://schemas.openxmlformats.org/drawingml/2006/main">
+            <a:r>
+              <a:t>3. 原文未在本页报告“提高 50% 效率”之类对照实验结果。</a:t>
+            </a:r>
+          </a:p>
+          <a:p xmlns:a="http://schemas.openxmlformats.org/drawingml/2006/main">
+            <a:r>
+              <a:t/>
+            </a:r>
+          </a:p>
+          <a:p xmlns:a="http://schemas.openxmlformats.org/drawingml/2006/main">
+            <a:r>
+              <a:t>&gt; 允许主张：文章提出一种三遍阅读法。</a:t>
+            </a:r>
+          </a:p>
+          <a:p xmlns:a="http://schemas.openxmlformats.org/drawingml/2006/main">
+            <a:r>
+              <a:t/>
+            </a:r>
+          </a:p>
+          <a:p xmlns:a="http://schemas.openxmlformats.org/drawingml/2006/main">
+            <a:r>
+              <a:t>教师讲述：</a:t>
+            </a:r>
+          </a:p>
+          <a:p xmlns:a="http://schemas.openxmlformats.org/drawingml/2006/main">
+            <a:r>
+              <a:t>这一页从元数据核验推进到原文主张核验。页面显示的 PDF 是真实来源，不是仿造界面。</a:t>
+            </a:r>
+          </a:p>
+          <a:p xmlns:a="http://schemas.openxmlformats.org/drawingml/2006/main">
+            <a:r>
+              <a:t/>
+            </a:r>
+          </a:p>
+          <a:p xmlns:a="http://schemas.openxmlformats.org/drawingml/2006/main">
+            <a:r>
+              <a:t>学生动作：</a:t>
+            </a:r>
+          </a:p>
+          <a:p xmlns:a="http://schemas.openxmlformats.org/drawingml/2006/main">
+            <a:r>
+              <a:t>让学生指出：如果 AI 声称“三遍法已证明提高 50% 效率”，下一步应定位什么证据？</a:t>
+            </a:r>
+          </a:p>
+          <a:p xmlns:a="http://schemas.openxmlformats.org/drawingml/2006/main">
+            <a:r>
+              <a:t/>
+            </a:r>
+          </a:p>
+          <a:p xmlns:a="http://schemas.openxmlformats.org/drawingml/2006/main">
+            <a:r>
+              <a:t>来源与边界：</a:t>
+            </a:r>
+          </a:p>
+          <a:p xmlns:a="http://schemas.openxmlformats.org/drawingml/2006/main">
+            <a:r>
+              <a:t>- Keshav, S. "How to Read a Paper." DOI: https://doi.org/10.1145/1273445.1273458</a:t>
+            </a:r>
+          </a:p>
+          <a:p xmlns:a="http://schemas.openxmlformats.org/drawingml/2006/main">
+            <a:r>
+              <a:t>- 公开 PDF：https://cs.uwaterloo.ca/~Brecht/courses/856/readings/how-to-read/keshav-paper-reading.pdf</a:t>
+            </a:r>
+          </a:p>
+          <a:p xmlns:a="http://schemas.openxmlformats.org/drawingml/2006/main">
+            <a:r>
+              <a:t/>
+            </a:r>
+          </a:p>
+          <a:p xmlns:a="http://schemas.openxmlformats.org/drawingml/2006/main">
+            <a:r>
+              <a:t>---</a:t>
+            </a:r>
+          </a:p>
+          <a:p xmlns:a="http://schemas.openxmlformats.org/drawingml/2006/main">
+            <a:r>
+              <a:t/>
             </a:r>
           </a:p>
           <a:p xmlns:a="http://schemas.openxmlformats.org/drawingml/2006/main">
@@ -843,7 +1618,17 @@
           </a:p>
           <a:p xmlns:a="http://schemas.openxmlformats.org/drawingml/2006/main">
             <a:r>
-              <a:t>- 本页仅使用课程内部规则与教学材料。</a:t>
+              <a:t/>
+            </a:r>
+          </a:p>
+          <a:p xmlns:a="http://schemas.openxmlformats.org/drawingml/2006/main">
+            <a:r>
+              <a:t>- 本课 handout.md 与 slides.md</a:t>
+            </a:r>
+          </a:p>
+          <a:p xmlns:a="http://schemas.openxmlformats.org/drawingml/2006/main">
+            <a:r>
+              <a:t/>
             </a:r>
           </a:p>
           <a:p xmlns:a="http://schemas.openxmlformats.org/drawingml/2006/main">
@@ -918,7 +1703,137 @@
           <a:lstStyle xmlns:a="http://schemas.openxmlformats.org/drawingml/2006/main"/>
           <a:p xmlns:a="http://schemas.openxmlformats.org/drawingml/2006/main">
             <a:r>
-              <a:t>页面标题：演示：合格条目进入候选表</a:t>
+              <a:t>页面：P15 演示：合格条目进入候选表</a:t>
+            </a:r>
+          </a:p>
+          <a:p xmlns:a="http://schemas.openxmlformats.org/drawingml/2006/main">
+            <a:r>
+              <a:t/>
+            </a:r>
+          </a:p>
+          <a:p xmlns:a="http://schemas.openxmlformats.org/drawingml/2006/main">
+            <a:r>
+              <a:t>讲义位置：本课讲义；见逐页母稿映射表</a:t>
+            </a:r>
+          </a:p>
+          <a:p xmlns:a="http://schemas.openxmlformats.org/drawingml/2006/main">
+            <a:r>
+              <a:t/>
+            </a:r>
+          </a:p>
+          <a:p xmlns:a="http://schemas.openxmlformats.org/drawingml/2006/main">
+            <a:r>
+              <a:t>屏显核对：</a:t>
+            </a:r>
+          </a:p>
+          <a:p xmlns:a="http://schemas.openxmlformats.org/drawingml/2006/main">
+            <a:r>
+              <a:t>真实候选条目｜Keshav (2007)</a:t>
+            </a:r>
+          </a:p>
+          <a:p xmlns:a="http://schemas.openxmlformats.org/drawingml/2006/main">
+            <a:r>
+              <a:t/>
+            </a:r>
+          </a:p>
+          <a:p xmlns:a="http://schemas.openxmlformats.org/drawingml/2006/main">
+            <a:r>
+              <a:t>| 字段 | 核验后写入 |</a:t>
+            </a:r>
+          </a:p>
+          <a:p xmlns:a="http://schemas.openxmlformats.org/drawingml/2006/main">
+            <a:r>
+              <a:t>| --- | --- |</a:t>
+            </a:r>
+          </a:p>
+          <a:p xmlns:a="http://schemas.openxmlformats.org/drawingml/2006/main">
+            <a:r>
+              <a:t>| 正式来源 | *ACM SIGCOMM Computer Communication Review* 37(3), pp.83–84；DOI `10.1145/1273445.1273458` |</a:t>
+            </a:r>
+          </a:p>
+          <a:p xmlns:a="http://schemas.openxmlformats.org/drawingml/2006/main">
+            <a:r>
+              <a:t>| 对应问题/拟用主张 | 是否降低遗漏率？／用于定义 three-pass approach |</a:t>
+            </a:r>
+          </a:p>
+          <a:p xmlns:a="http://schemas.openxmlformats.org/drawingml/2006/main">
+            <a:r>
+              <a:t>| 预期证据角色 | 探索线索；不是效果主证据 |</a:t>
+            </a:r>
+          </a:p>
+          <a:p xmlns:a="http://schemas.openxmlformats.org/drawingml/2006/main">
+            <a:r>
+              <a:t>| 核验状态 | `verified-with-caveat`：缺少受控效果实验，保留限定 |</a:t>
+            </a:r>
+          </a:p>
+          <a:p xmlns:a="http://schemas.openxmlformats.org/drawingml/2006/main">
+            <a:r>
+              <a:t/>
+            </a:r>
+          </a:p>
+          <a:p xmlns:a="http://schemas.openxmlformats.org/drawingml/2006/main">
+            <a:r>
+              <a:t>角色与状态独立：它已完成入口核验，但相对于当前效果问题仍是探索线索。</a:t>
+            </a:r>
+          </a:p>
+          <a:p xmlns:a="http://schemas.openxmlformats.org/drawingml/2006/main">
+            <a:r>
+              <a:t/>
+            </a:r>
+          </a:p>
+          <a:p xmlns:a="http://schemas.openxmlformats.org/drawingml/2006/main">
+            <a:r>
+              <a:t>教师讲述：</a:t>
+            </a:r>
+          </a:p>
+          <a:p xmlns:a="http://schemas.openxmlformats.org/drawingml/2006/main">
+            <a:r>
+              <a:t>Keshav 文章已被核验为真实来源，允许主张也能定位到原文；但它不直接回答“是否降低遗漏率”。因此状态是 `verified-with-caveat`，当前角色仍是探索线索。改变问题或拟用主张时，角色可以改变，状态不会因此自动改变。</a:t>
+            </a:r>
+          </a:p>
+          <a:p xmlns:a="http://schemas.openxmlformats.org/drawingml/2006/main">
+            <a:r>
+              <a:t/>
+            </a:r>
+          </a:p>
+          <a:p xmlns:a="http://schemas.openxmlformats.org/drawingml/2006/main">
+            <a:r>
+              <a:t>学生动作：</a:t>
+            </a:r>
+          </a:p>
+          <a:p xmlns:a="http://schemas.openxmlformats.org/drawingml/2006/main">
+            <a:r>
+              <a:t>无。进入下一页判断点。</a:t>
+            </a:r>
+          </a:p>
+          <a:p xmlns:a="http://schemas.openxmlformats.org/drawingml/2006/main">
+            <a:r>
+              <a:t/>
+            </a:r>
+          </a:p>
+          <a:p xmlns:a="http://schemas.openxmlformats.org/drawingml/2006/main">
+            <a:r>
+              <a:t>来源与边界：</a:t>
+            </a:r>
+          </a:p>
+          <a:p xmlns:a="http://schemas.openxmlformats.org/drawingml/2006/main">
+            <a:r>
+              <a:t>讲义 §五 候选文献表；[starter-template.md](../../course/starter-template.md) 工件追踪。</a:t>
+            </a:r>
+          </a:p>
+          <a:p xmlns:a="http://schemas.openxmlformats.org/drawingml/2006/main">
+            <a:r>
+              <a:t/>
+            </a:r>
+          </a:p>
+          <a:p xmlns:a="http://schemas.openxmlformats.org/drawingml/2006/main">
+            <a:r>
+              <a:t>---</a:t>
+            </a:r>
+          </a:p>
+          <a:p xmlns:a="http://schemas.openxmlformats.org/drawingml/2006/main">
+            <a:r>
+              <a:t/>
             </a:r>
           </a:p>
           <a:p xmlns:a="http://schemas.openxmlformats.org/drawingml/2006/main">
@@ -928,7 +1843,17 @@
           </a:p>
           <a:p xmlns:a="http://schemas.openxmlformats.org/drawingml/2006/main">
             <a:r>
-              <a:t>- 本页仅使用课程内部规则与教学材料。</a:t>
+              <a:t/>
+            </a:r>
+          </a:p>
+          <a:p xmlns:a="http://schemas.openxmlformats.org/drawingml/2006/main">
+            <a:r>
+              <a:t>- 本课 handout.md 与 slides.md</a:t>
+            </a:r>
+          </a:p>
+          <a:p xmlns:a="http://schemas.openxmlformats.org/drawingml/2006/main">
+            <a:r>
+              <a:t/>
             </a:r>
           </a:p>
           <a:p xmlns:a="http://schemas.openxmlformats.org/drawingml/2006/main">
@@ -1003,7 +1928,182 @@
           <a:lstStyle xmlns:a="http://schemas.openxmlformats.org/drawingml/2006/main"/>
           <a:p xmlns:a="http://schemas.openxmlformats.org/drawingml/2006/main">
             <a:r>
-              <a:t>页面标题：真实失败演示：教师自己的幻觉引用审计</a:t>
+              <a:t>页面：P16 真实失败演示：教师自己的幻觉引用审计</a:t>
+            </a:r>
+          </a:p>
+          <a:p xmlns:a="http://schemas.openxmlformats.org/drawingml/2006/main">
+            <a:r>
+              <a:t/>
+            </a:r>
+          </a:p>
+          <a:p xmlns:a="http://schemas.openxmlformats.org/drawingml/2006/main">
+            <a:r>
+              <a:t>讲义位置：本课讲义；见逐页母稿映射表</a:t>
+            </a:r>
+          </a:p>
+          <a:p xmlns:a="http://schemas.openxmlformats.org/drawingml/2006/main">
+            <a:r>
+              <a:t/>
+            </a:r>
+          </a:p>
+          <a:p xmlns:a="http://schemas.openxmlformats.org/drawingml/2006/main">
+            <a:r>
+              <a:t>屏显核对：</a:t>
+            </a:r>
+          </a:p>
+          <a:p xmlns:a="http://schemas.openxmlformats.org/drawingml/2006/main">
+            <a:r>
+              <a:t>案例边界框：本页为教师真实检索失败 trace（公开 arXiv 元数据，记录于 mi-search-trace-demo.md §6）；学生练习仍用讲义 §四·5 虚构案例</a:t>
+            </a:r>
+          </a:p>
+          <a:p xmlns:a="http://schemas.openxmlformats.org/drawingml/2006/main">
+            <a:r>
+              <a:t/>
+            </a:r>
+          </a:p>
+          <a:p xmlns:a="http://schemas.openxmlformats.org/drawingml/2006/main">
+            <a:r>
+              <a:t>教师 AI agent 凭记忆给出 11 个 MI 锚点 ID——抽查即错 6 个，其中 4 条彻底张冠李戴：</a:t>
+            </a:r>
+          </a:p>
+          <a:p xmlns:a="http://schemas.openxmlformats.org/drawingml/2006/main">
+            <a:r>
+              <a:t/>
+            </a:r>
+          </a:p>
+          <a:p xmlns:a="http://schemas.openxmlformats.org/drawingml/2006/main">
+            <a:r>
+              <a:t>| 记忆条目 | 实为 | 处置 |</a:t>
+            </a:r>
+          </a:p>
+          <a:p xmlns:a="http://schemas.openxmlformats.org/drawingml/2006/main">
+            <a:r>
+              <a:t>| --- | --- | --- |</a:t>
+            </a:r>
+          </a:p>
+          <a:p xmlns:a="http://schemas.openxmlformats.org/drawingml/2006/main">
+            <a:r>
+              <a:t>| 2308.10939＝Attribution Patching | 凝聚态物理论文 | `rejected` |</a:t>
+            </a:r>
+          </a:p>
+          <a:p xmlns:a="http://schemas.openxmlformats.org/drawingml/2006/main">
+            <a:r>
+              <a:t>| 2203.13787＝Tuned Lens | 混合序列预测论文 | `rejected` |</a:t>
+            </a:r>
+          </a:p>
+          <a:p xmlns:a="http://schemas.openxmlformats.org/drawingml/2006/main">
+            <a:r>
+              <a:t>| 2309.10655＝Emergent Linear Representations | 路径规划论文 | `rejected` |</a:t>
+            </a:r>
+          </a:p>
+          <a:p xmlns:a="http://schemas.openxmlformats.org/drawingml/2006/main">
+            <a:r>
+              <a:t>| 2407.14400＝Gemma Scope | O-RAN 网络预测论文 | `rejected` |</a:t>
+            </a:r>
+          </a:p>
+          <a:p xmlns:a="http://schemas.openxmlformats.org/drawingml/2006/main">
+            <a:r>
+              <a:t/>
+            </a:r>
+          </a:p>
+          <a:p xmlns:a="http://schemas.openxmlformats.org/drawingml/2006/main">
+            <a:r>
+              <a:t>恢复路径：`ti:` 题名检索恢复正确 ID（2310.10348 / 2303.08112 / 2309.00941 / 2408.05147）；失败保留留档，不重跑到无痕。</a:t>
+            </a:r>
+          </a:p>
+          <a:p xmlns:a="http://schemas.openxmlformats.org/drawingml/2006/main">
+            <a:r>
+              <a:t/>
+            </a:r>
+          </a:p>
+          <a:p xmlns:a="http://schemas.openxmlformats.org/drawingml/2006/main">
+            <a:r>
+              <a:t>四个判断点：</a:t>
+            </a:r>
+          </a:p>
+          <a:p xmlns:a="http://schemas.openxmlformats.org/drawingml/2006/main">
+            <a:r>
+              <a:t>1. 为什么先写问题再搜材料？</a:t>
+            </a:r>
+          </a:p>
+          <a:p xmlns:a="http://schemas.openxmlformats.org/drawingml/2006/main">
+            <a:r>
+              <a:t>2. 纳入/排除是检索前还是后写的？</a:t>
+            </a:r>
+          </a:p>
+          <a:p xmlns:a="http://schemas.openxmlformats.org/drawingml/2006/main">
+            <a:r>
+              <a:t>3. 角色、状态和筛选决定分别回答什么？</a:t>
+            </a:r>
+          </a:p>
+          <a:p xmlns:a="http://schemas.openxmlformats.org/drawingml/2006/main">
+            <a:r>
+              <a:t>4. `verified-with-caveat` 如何在候选表保留限定？</a:t>
+            </a:r>
+          </a:p>
+          <a:p xmlns:a="http://schemas.openxmlformats.org/drawingml/2006/main">
+            <a:r>
+              <a:t/>
+            </a:r>
+          </a:p>
+          <a:p xmlns:a="http://schemas.openxmlformats.org/drawingml/2006/main">
+            <a:r>
+              <a:t>教师讲述：</a:t>
+            </a:r>
+          </a:p>
+          <a:p xmlns:a="http://schemas.openxmlformats.org/drawingml/2006/main">
+            <a:r>
+              <a:t>失败对象是教师自己的真实检索记录，不是构造样例：记忆与模型输出的 ID 必须逐条回正式来源核验，`rejected` 永不入候选表。结论不是"AI 不可用"，而是恢复路径留档后照样能找回正确文献。学生练习对象仍是讲义 §四·5 的虚构论文 A–E，避免练习变成演示复刻；该虚构表标注"不得引用"的纪律不变。</a:t>
+            </a:r>
+          </a:p>
+          <a:p xmlns:a="http://schemas.openxmlformats.org/drawingml/2006/main">
+            <a:r>
+              <a:t/>
+            </a:r>
+          </a:p>
+          <a:p xmlns:a="http://schemas.openxmlformats.org/drawingml/2006/main">
+            <a:r>
+              <a:t>学生动作：</a:t>
+            </a:r>
+          </a:p>
+          <a:p xmlns:a="http://schemas.openxmlformats.org/drawingml/2006/main">
+            <a:r>
+              <a:t>现场请学生给出一条核验步骤，教师把它加入改写后的任务契约。</a:t>
+            </a:r>
+          </a:p>
+          <a:p xmlns:a="http://schemas.openxmlformats.org/drawingml/2006/main">
+            <a:r>
+              <a:t/>
+            </a:r>
+          </a:p>
+          <a:p xmlns:a="http://schemas.openxmlformats.org/drawingml/2006/main">
+            <a:r>
+              <a:t>来源与边界：</a:t>
+            </a:r>
+          </a:p>
+          <a:p xmlns:a="http://schemas.openxmlformats.org/drawingml/2006/main">
+            <a:r>
+              <a:t>- 真实材料：[mi-search-trace-demo.md](./mi-search-trace-demo.md) §6（4 条真实 rejected 与恢复路径，公开 arXiv 元数据）；案例边界框见该文件开头。</a:t>
+            </a:r>
+          </a:p>
+          <a:p xmlns:a="http://schemas.openxmlformats.org/drawingml/2006/main">
+            <a:r>
+              <a:t>- 状态规则见讲义 §四·3；学生练习用虚构表见讲义 §四·5（课堂构造，不得引用）。</a:t>
+            </a:r>
+          </a:p>
+          <a:p xmlns:a="http://schemas.openxmlformats.org/drawingml/2006/main">
+            <a:r>
+              <a:t/>
+            </a:r>
+          </a:p>
+          <a:p xmlns:a="http://schemas.openxmlformats.org/drawingml/2006/main">
+            <a:r>
+              <a:t>---</a:t>
+            </a:r>
+          </a:p>
+          <a:p xmlns:a="http://schemas.openxmlformats.org/drawingml/2006/main">
+            <a:r>
+              <a:t/>
             </a:r>
           </a:p>
           <a:p xmlns:a="http://schemas.openxmlformats.org/drawingml/2006/main">
@@ -1013,7 +2113,17 @@
           </a:p>
           <a:p xmlns:a="http://schemas.openxmlformats.org/drawingml/2006/main">
             <a:r>
-              <a:t>- 本页仅使用课程内部规则与教学材料。</a:t>
+              <a:t/>
+            </a:r>
+          </a:p>
+          <a:p xmlns:a="http://schemas.openxmlformats.org/drawingml/2006/main">
+            <a:r>
+              <a:t>- 本课 handout.md 与 slides.md</a:t>
+            </a:r>
+          </a:p>
+          <a:p xmlns:a="http://schemas.openxmlformats.org/drawingml/2006/main">
+            <a:r>
+              <a:t/>
             </a:r>
           </a:p>
           <a:p xmlns:a="http://schemas.openxmlformats.org/drawingml/2006/main">
@@ -1088,7 +2198,172 @@
           <a:lstStyle xmlns:a="http://schemas.openxmlformats.org/drawingml/2006/main"/>
           <a:p xmlns:a="http://schemas.openxmlformats.org/drawingml/2006/main">
             <a:r>
-              <a:t>页面标题：个人实践：跑通一次可复盘检索</a:t>
+              <a:t>页面：P17 个人实践：跑通一次可复盘检索</a:t>
+            </a:r>
+          </a:p>
+          <a:p xmlns:a="http://schemas.openxmlformats.org/drawingml/2006/main">
+            <a:r>
+              <a:t/>
+            </a:r>
+          </a:p>
+          <a:p xmlns:a="http://schemas.openxmlformats.org/drawingml/2006/main">
+            <a:r>
+              <a:t>讲义位置：本课讲义；见逐页母稿映射表</a:t>
+            </a:r>
+          </a:p>
+          <a:p xmlns:a="http://schemas.openxmlformats.org/drawingml/2006/main">
+            <a:r>
+              <a:t/>
+            </a:r>
+          </a:p>
+          <a:p xmlns:a="http://schemas.openxmlformats.org/drawingml/2006/main">
+            <a:r>
+              <a:t>屏显核对：</a:t>
+            </a:r>
+          </a:p>
+          <a:p xmlns:a="http://schemas.openxmlformats.org/drawingml/2006/main">
+            <a:r>
+              <a:t>本轮完成：</a:t>
+            </a:r>
+          </a:p>
+          <a:p xmlns:a="http://schemas.openxmlformats.org/drawingml/2006/main">
+            <a:r>
+              <a:t>1. 写下你的研究问题（没有者沿用贯穿案例）</a:t>
+            </a:r>
+          </a:p>
+          <a:p xmlns:a="http://schemas.openxmlformats.org/drawingml/2006/main">
+            <a:r>
+              <a:t>2. 抽 5 个关键词 + 同义/上位词</a:t>
+            </a:r>
+          </a:p>
+          <a:p xmlns:a="http://schemas.openxmlformats.org/drawingml/2006/main">
+            <a:r>
+              <a:t>3. 构造一条检索式</a:t>
+            </a:r>
+          </a:p>
+          <a:p xmlns:a="http://schemas.openxmlformats.org/drawingml/2006/main">
+            <a:r>
+              <a:t>4. 让 AI 围绕问题生成 3-5 条文献线索</a:t>
+            </a:r>
+          </a:p>
+          <a:p xmlns:a="http://schemas.openxmlformats.org/drawingml/2006/main">
+            <a:r>
+              <a:t>5. 对至少 2 条执行入口核验</a:t>
+            </a:r>
+          </a:p>
+          <a:p xmlns:a="http://schemas.openxmlformats.org/drawingml/2006/main">
+            <a:r>
+              <a:t>6. 审计至少 2 条，一条保留 pending/rejected</a:t>
+            </a:r>
+          </a:p>
+          <a:p xmlns:a="http://schemas.openxmlformats.org/drawingml/2006/main">
+            <a:r>
+              <a:t>7. 标证据角色</a:t>
+            </a:r>
+          </a:p>
+          <a:p xmlns:a="http://schemas.openxmlformats.org/drawingml/2006/main">
+            <a:r>
+              <a:t>8. 写一条 AI 使用记录</a:t>
+            </a:r>
+          </a:p>
+          <a:p xmlns:a="http://schemas.openxmlformats.org/drawingml/2006/main">
+            <a:r>
+              <a:t/>
+            </a:r>
+          </a:p>
+          <a:p xmlns:a="http://schemas.openxmlformats.org/drawingml/2006/main">
+            <a:r>
+              <a:t>选择顺序：本人真实问题 → 导师组公开问题 → 课程贯穿案例</a:t>
+            </a:r>
+          </a:p>
+          <a:p xmlns:a="http://schemas.openxmlformats.org/drawingml/2006/main">
+            <a:r>
+              <a:t/>
+            </a:r>
+          </a:p>
+          <a:p xmlns:a="http://schemas.openxmlformats.org/drawingml/2006/main">
+            <a:r>
+              <a:t>教师讲述：</a:t>
+            </a:r>
+          </a:p>
+          <a:p xmlns:a="http://schemas.openxmlformats.org/drawingml/2006/main">
+            <a:r>
+              <a:t>没有真实课题的学生不应掉队。沿用贯穿案例只用于启动方法练习。本课实践动作不得与教师演示同题，避免把个人实践变成演示的复刻——若用贯穿案例，请改换问题表述或检索词集合。</a:t>
+            </a:r>
+          </a:p>
+          <a:p xmlns:a="http://schemas.openxmlformats.org/drawingml/2006/main">
+            <a:r>
+              <a:t/>
+            </a:r>
+          </a:p>
+          <a:p xmlns:a="http://schemas.openxmlformats.org/drawingml/2006/main">
+            <a:r>
+              <a:t>验收标准：</a:t>
+            </a:r>
+          </a:p>
+          <a:p xmlns:a="http://schemas.openxmlformats.org/drawingml/2006/main">
+            <a:r>
+              <a:t>- 检索记录含库、式、日期、命中数、纳入排除；</a:t>
+            </a:r>
+          </a:p>
+          <a:p xmlns:a="http://schemas.openxmlformats.org/drawingml/2006/main">
+            <a:r>
+              <a:t>- 来源审计至少 2 条，状态按实际核验结果记录，不凑出错误；</a:t>
+            </a:r>
+          </a:p>
+          <a:p xmlns:a="http://schemas.openxmlformats.org/drawingml/2006/main">
+            <a:r>
+              <a:t>- 候选表至少 1 条 verified 或带完整限定的 verified-with-caveat，并标证据角色；</a:t>
+            </a:r>
+          </a:p>
+          <a:p xmlns:a="http://schemas.openxmlformats.org/drawingml/2006/main">
+            <a:r>
+              <a:t>- AI 使用记录完整。</a:t>
+            </a:r>
+          </a:p>
+          <a:p xmlns:a="http://schemas.openxmlformats.org/drawingml/2006/main">
+            <a:r>
+              <a:t/>
+            </a:r>
+          </a:p>
+          <a:p xmlns:a="http://schemas.openxmlformats.org/drawingml/2006/main">
+            <a:r>
+              <a:t>学生动作：</a:t>
+            </a:r>
+          </a:p>
+          <a:p xmlns:a="http://schemas.openxmlformats.org/drawingml/2006/main">
+            <a:r>
+              <a:t>用本页说明任务并确认备用路径。</a:t>
+            </a:r>
+          </a:p>
+          <a:p xmlns:a="http://schemas.openxmlformats.org/drawingml/2006/main">
+            <a:r>
+              <a:t/>
+            </a:r>
+          </a:p>
+          <a:p xmlns:a="http://schemas.openxmlformats.org/drawingml/2006/main">
+            <a:r>
+              <a:t>来源与边界：</a:t>
+            </a:r>
+          </a:p>
+          <a:p xmlns:a="http://schemas.openxmlformats.org/drawingml/2006/main">
+            <a:r>
+              <a:t>[starter-template.md](../../course/starter-template.md) 最小文件结构；第 1-2 课项目工件。</a:t>
+            </a:r>
+          </a:p>
+          <a:p xmlns:a="http://schemas.openxmlformats.org/drawingml/2006/main">
+            <a:r>
+              <a:t/>
+            </a:r>
+          </a:p>
+          <a:p xmlns:a="http://schemas.openxmlformats.org/drawingml/2006/main">
+            <a:r>
+              <a:t>---</a:t>
+            </a:r>
+          </a:p>
+          <a:p xmlns:a="http://schemas.openxmlformats.org/drawingml/2006/main">
+            <a:r>
+              <a:t/>
             </a:r>
           </a:p>
           <a:p xmlns:a="http://schemas.openxmlformats.org/drawingml/2006/main">
@@ -1098,7 +2373,17 @@
           </a:p>
           <a:p xmlns:a="http://schemas.openxmlformats.org/drawingml/2006/main">
             <a:r>
-              <a:t>- 本页仅使用课程内部规则与教学材料。</a:t>
+              <a:t/>
+            </a:r>
+          </a:p>
+          <a:p xmlns:a="http://schemas.openxmlformats.org/drawingml/2006/main">
+            <a:r>
+              <a:t>- 本课 handout.md 与 slides.md</a:t>
+            </a:r>
+          </a:p>
+          <a:p xmlns:a="http://schemas.openxmlformats.org/drawingml/2006/main">
+            <a:r>
+              <a:t/>
             </a:r>
           </a:p>
           <a:p xmlns:a="http://schemas.openxmlformats.org/drawingml/2006/main">
@@ -1173,7 +2458,207 @@
           <a:lstStyle xmlns:a="http://schemas.openxmlformats.org/drawingml/2006/main"/>
           <a:p xmlns:a="http://schemas.openxmlformats.org/drawingml/2006/main">
             <a:r>
-              <a:t>页面标题：实践停留页：模板</a:t>
+              <a:t>页面：P18 实践停留页：模板</a:t>
+            </a:r>
+          </a:p>
+          <a:p xmlns:a="http://schemas.openxmlformats.org/drawingml/2006/main">
+            <a:r>
+              <a:t/>
+            </a:r>
+          </a:p>
+          <a:p xmlns:a="http://schemas.openxmlformats.org/drawingml/2006/main">
+            <a:r>
+              <a:t>讲义位置：本课讲义；见逐页母稿映射表</a:t>
+            </a:r>
+          </a:p>
+          <a:p xmlns:a="http://schemas.openxmlformats.org/drawingml/2006/main">
+            <a:r>
+              <a:t/>
+            </a:r>
+          </a:p>
+          <a:p xmlns:a="http://schemas.openxmlformats.org/drawingml/2006/main">
+            <a:r>
+              <a:t>屏显核对：</a:t>
+            </a:r>
+          </a:p>
+          <a:p xmlns:a="http://schemas.openxmlformats.org/drawingml/2006/main">
+            <a:r>
+              <a:t>检索记录模板：</a:t>
+            </a:r>
+          </a:p>
+          <a:p xmlns:a="http://schemas.openxmlformats.org/drawingml/2006/main">
+            <a:r>
+              <a:t/>
+            </a:r>
+          </a:p>
+          <a:p xmlns:a="http://schemas.openxmlformats.org/drawingml/2006/main">
+            <a:r>
+              <a:t>```text</a:t>
+            </a:r>
+          </a:p>
+          <a:p xmlns:a="http://schemas.openxmlformats.org/drawingml/2006/main">
+            <a:r>
+              <a:t>库：</a:t>
+            </a:r>
+          </a:p>
+          <a:p xmlns:a="http://schemas.openxmlformats.org/drawingml/2006/main">
+            <a:r>
+              <a:t>检索式：</a:t>
+            </a:r>
+          </a:p>
+          <a:p xmlns:a="http://schemas.openxmlformats.org/drawingml/2006/main">
+            <a:r>
+              <a:t>日期：</a:t>
+            </a:r>
+          </a:p>
+          <a:p xmlns:a="http://schemas.openxmlformats.org/drawingml/2006/main">
+            <a:r>
+              <a:t>时间范围：</a:t>
+            </a:r>
+          </a:p>
+          <a:p xmlns:a="http://schemas.openxmlformats.org/drawingml/2006/main">
+            <a:r>
+              <a:t>命中数：</a:t>
+            </a:r>
+          </a:p>
+          <a:p xmlns:a="http://schemas.openxmlformats.org/drawingml/2006/main">
+            <a:r>
+              <a:t>纳入条件：</a:t>
+            </a:r>
+          </a:p>
+          <a:p xmlns:a="http://schemas.openxmlformats.org/drawingml/2006/main">
+            <a:r>
+              <a:t>排除条件：</a:t>
+            </a:r>
+          </a:p>
+          <a:p xmlns:a="http://schemas.openxmlformats.org/drawingml/2006/main">
+            <a:r>
+              <a:t>筛选后：</a:t>
+            </a:r>
+          </a:p>
+          <a:p xmlns:a="http://schemas.openxmlformats.org/drawingml/2006/main">
+            <a:r>
+              <a:t>```</a:t>
+            </a:r>
+          </a:p>
+          <a:p xmlns:a="http://schemas.openxmlformats.org/drawingml/2006/main">
+            <a:r>
+              <a:t/>
+            </a:r>
+          </a:p>
+          <a:p xmlns:a="http://schemas.openxmlformats.org/drawingml/2006/main">
+            <a:r>
+              <a:t>候选文献表模板（只放纳入且非 `rejected` 的条目）：</a:t>
+            </a:r>
+          </a:p>
+          <a:p xmlns:a="http://schemas.openxmlformats.org/drawingml/2006/main">
+            <a:r>
+              <a:t/>
+            </a:r>
+          </a:p>
+          <a:p xmlns:a="http://schemas.openxmlformats.org/drawingml/2006/main">
+            <a:r>
+              <a:t>```text</a:t>
+            </a:r>
+          </a:p>
+          <a:p xmlns:a="http://schemas.openxmlformats.org/drawingml/2006/main">
+            <a:r>
+              <a:t>| 编号 | 题名（核验后） | 作者 | 年份 | 稳定来源 | 对应问题/拟用主张 | 预期证据角色 | 纳入理由 | 核验状态 | caveat/允许主张 |</a:t>
+            </a:r>
+          </a:p>
+          <a:p xmlns:a="http://schemas.openxmlformats.org/drawingml/2006/main">
+            <a:r>
+              <a:t>```</a:t>
+            </a:r>
+          </a:p>
+          <a:p xmlns:a="http://schemas.openxmlformats.org/drawingml/2006/main">
+            <a:r>
+              <a:t/>
+            </a:r>
+          </a:p>
+          <a:p xmlns:a="http://schemas.openxmlformats.org/drawingml/2006/main">
+            <a:r>
+              <a:t>另建：检索与筛选记录（含排除理由）｜来源审计记录（含 rejected）</a:t>
+            </a:r>
+          </a:p>
+          <a:p xmlns:a="http://schemas.openxmlformats.org/drawingml/2006/main">
+            <a:r>
+              <a:t/>
+            </a:r>
+          </a:p>
+          <a:p xmlns:a="http://schemas.openxmlformats.org/drawingml/2006/main">
+            <a:r>
+              <a:t>统一写入：notes/literature-search.md</a:t>
+            </a:r>
+          </a:p>
+          <a:p xmlns:a="http://schemas.openxmlformats.org/drawingml/2006/main">
+            <a:r>
+              <a:t/>
+            </a:r>
+          </a:p>
+          <a:p xmlns:a="http://schemas.openxmlformats.org/drawingml/2006/main">
+            <a:r>
+              <a:t>最低完成：1 条检索记录｜2 条来源审计｜1 条已核验候选记录｜1 条 AI 记录</a:t>
+            </a:r>
+          </a:p>
+          <a:p xmlns:a="http://schemas.openxmlformats.org/drawingml/2006/main">
+            <a:r>
+              <a:t/>
+            </a:r>
+          </a:p>
+          <a:p xmlns:a="http://schemas.openxmlformats.org/drawingml/2006/main">
+            <a:r>
+              <a:t>教师讲述：</a:t>
+            </a:r>
+          </a:p>
+          <a:p xmlns:a="http://schemas.openxmlformats.org/drawingml/2006/main">
+            <a:r>
+              <a:t>模板投屏停留。学生可照抄到个人项目。本课不正式提交；第 4-6 课继续回写，第 6 课问题门统一检查。</a:t>
+            </a:r>
+          </a:p>
+          <a:p xmlns:a="http://schemas.openxmlformats.org/drawingml/2006/main">
+            <a:r>
+              <a:t/>
+            </a:r>
+          </a:p>
+          <a:p xmlns:a="http://schemas.openxmlformats.org/drawingml/2006/main">
+            <a:r>
+              <a:t>学生动作：</a:t>
+            </a:r>
+          </a:p>
+          <a:p xmlns:a="http://schemas.openxmlformats.org/drawingml/2006/main">
+            <a:r>
+              <a:t>第一段完成检索式与两条审计后，教师用一个身份已核验但主张未核验的反例做共性点评；第二段再将一条合格记录写入候选表并补 AI 使用记录。库访问故障者使用 [source-audit-demo.md](./source-audit-demo.md) 完成 1 条真实核验，自有条目保持 `pending`。</a:t>
+            </a:r>
+          </a:p>
+          <a:p xmlns:a="http://schemas.openxmlformats.org/drawingml/2006/main">
+            <a:r>
+              <a:t/>
+            </a:r>
+          </a:p>
+          <a:p xmlns:a="http://schemas.openxmlformats.org/drawingml/2006/main">
+            <a:r>
+              <a:t>来源与边界：</a:t>
+            </a:r>
+          </a:p>
+          <a:p xmlns:a="http://schemas.openxmlformats.org/drawingml/2006/main">
+            <a:r>
+              <a:t>讲义 §五 候选文献表；§二 检索记录字段。</a:t>
+            </a:r>
+          </a:p>
+          <a:p xmlns:a="http://schemas.openxmlformats.org/drawingml/2006/main">
+            <a:r>
+              <a:t/>
+            </a:r>
+          </a:p>
+          <a:p xmlns:a="http://schemas.openxmlformats.org/drawingml/2006/main">
+            <a:r>
+              <a:t>---</a:t>
+            </a:r>
+          </a:p>
+          <a:p xmlns:a="http://schemas.openxmlformats.org/drawingml/2006/main">
+            <a:r>
+              <a:t/>
             </a:r>
           </a:p>
           <a:p xmlns:a="http://schemas.openxmlformats.org/drawingml/2006/main">
@@ -1183,7 +2668,17 @@
           </a:p>
           <a:p xmlns:a="http://schemas.openxmlformats.org/drawingml/2006/main">
             <a:r>
-              <a:t>- 本页仅使用课程内部规则与教学材料。</a:t>
+              <a:t/>
+            </a:r>
+          </a:p>
+          <a:p xmlns:a="http://schemas.openxmlformats.org/drawingml/2006/main">
+            <a:r>
+              <a:t>- 本课 handout.md 与 slides.md</a:t>
+            </a:r>
+          </a:p>
+          <a:p xmlns:a="http://schemas.openxmlformats.org/drawingml/2006/main">
+            <a:r>
+              <a:t/>
             </a:r>
           </a:p>
           <a:p xmlns:a="http://schemas.openxmlformats.org/drawingml/2006/main">
@@ -1258,7 +2753,127 @@
           <a:lstStyle xmlns:a="http://schemas.openxmlformats.org/drawingml/2006/main"/>
           <a:p xmlns:a="http://schemas.openxmlformats.org/drawingml/2006/main">
             <a:r>
-              <a:t>页面标题：同伴互查三问</a:t>
+              <a:t>页面：P19 同伴互查三问</a:t>
+            </a:r>
+          </a:p>
+          <a:p xmlns:a="http://schemas.openxmlformats.org/drawingml/2006/main">
+            <a:r>
+              <a:t/>
+            </a:r>
+          </a:p>
+          <a:p xmlns:a="http://schemas.openxmlformats.org/drawingml/2006/main">
+            <a:r>
+              <a:t>讲义位置：本课讲义；见逐页母稿映射表</a:t>
+            </a:r>
+          </a:p>
+          <a:p xmlns:a="http://schemas.openxmlformats.org/drawingml/2006/main">
+            <a:r>
+              <a:t/>
+            </a:r>
+          </a:p>
+          <a:p xmlns:a="http://schemas.openxmlformats.org/drawingml/2006/main">
+            <a:r>
+              <a:t>屏显核对：</a:t>
+            </a:r>
+          </a:p>
+          <a:p xmlns:a="http://schemas.openxmlformats.org/drawingml/2006/main">
+            <a:r>
+              <a:t>两人互查三问：</a:t>
+            </a:r>
+          </a:p>
+          <a:p xmlns:a="http://schemas.openxmlformats.org/drawingml/2006/main">
+            <a:r>
+              <a:t>1. 检索可复盘吗？库、式、日期、命中数、筛选标准齐全吗？</a:t>
+            </a:r>
+          </a:p>
+          <a:p xmlns:a="http://schemas.openxmlformats.org/drawingml/2006/main">
+            <a:r>
+              <a:t>2. 预期角色有对应问题/拟用主张吗？是否与状态、筛选决定分开？</a:t>
+            </a:r>
+          </a:p>
+          <a:p xmlns:a="http://schemas.openxmlformats.org/drawingml/2006/main">
+            <a:r>
+              <a:t>3. 身份与一条拟用主张回原文了吗？`rejected` 和 `pending` 理由成立吗？</a:t>
+            </a:r>
+          </a:p>
+          <a:p xmlns:a="http://schemas.openxmlformats.org/drawingml/2006/main">
+            <a:r>
+              <a:t/>
+            </a:r>
+          </a:p>
+          <a:p xmlns:a="http://schemas.openxmlformats.org/drawingml/2006/main">
+            <a:r>
+              <a:t>作者记录：采纳／暂不采纳／待核验</a:t>
+            </a:r>
+          </a:p>
+          <a:p xmlns:a="http://schemas.openxmlformats.org/drawingml/2006/main">
+            <a:r>
+              <a:t/>
+            </a:r>
+          </a:p>
+          <a:p xmlns:a="http://schemas.openxmlformats.org/drawingml/2006/main">
+            <a:r>
+              <a:t>&gt; 同伴只提问题，不替作者决定。</a:t>
+            </a:r>
+          </a:p>
+          <a:p xmlns:a="http://schemas.openxmlformats.org/drawingml/2006/main">
+            <a:r>
+              <a:t/>
+            </a:r>
+          </a:p>
+          <a:p xmlns:a="http://schemas.openxmlformats.org/drawingml/2006/main">
+            <a:r>
+              <a:t>教师讲述：</a:t>
+            </a:r>
+          </a:p>
+          <a:p xmlns:a="http://schemas.openxmlformats.org/drawingml/2006/main">
+            <a:r>
+              <a:t>每人约 3-5 分钟：一人用 45 秒说明问题、检索式和一条核验；同伴按三问反馈；作者记录处理决定。反馈不要求立即改写。反馈者不替代作者修改，不形成共同提交。人数为奇数时组成三人组，每人缩短说明时间。</a:t>
+            </a:r>
+          </a:p>
+          <a:p xmlns:a="http://schemas.openxmlformats.org/drawingml/2006/main">
+            <a:r>
+              <a:t/>
+            </a:r>
+          </a:p>
+          <a:p xmlns:a="http://schemas.openxmlformats.org/drawingml/2006/main">
+            <a:r>
+              <a:t>学生动作：</a:t>
+            </a:r>
+          </a:p>
+          <a:p xmlns:a="http://schemas.openxmlformats.org/drawingml/2006/main">
+            <a:r>
+              <a:t>两人互查，按三问留下反馈记录。</a:t>
+            </a:r>
+          </a:p>
+          <a:p xmlns:a="http://schemas.openxmlformats.org/drawingml/2006/main">
+            <a:r>
+              <a:t/>
+            </a:r>
+          </a:p>
+          <a:p xmlns:a="http://schemas.openxmlformats.org/drawingml/2006/main">
+            <a:r>
+              <a:t>来源与边界：</a:t>
+            </a:r>
+          </a:p>
+          <a:p xmlns:a="http://schemas.openxmlformats.org/drawingml/2006/main">
+            <a:r>
+              <a:t>同伴反馈为形成性活动，不单独计分，不共同提交（[assignments.md](../../course/assignments.md)）。</a:t>
+            </a:r>
+          </a:p>
+          <a:p xmlns:a="http://schemas.openxmlformats.org/drawingml/2006/main">
+            <a:r>
+              <a:t/>
+            </a:r>
+          </a:p>
+          <a:p xmlns:a="http://schemas.openxmlformats.org/drawingml/2006/main">
+            <a:r>
+              <a:t>---</a:t>
+            </a:r>
+          </a:p>
+          <a:p xmlns:a="http://schemas.openxmlformats.org/drawingml/2006/main">
+            <a:r>
+              <a:t/>
             </a:r>
           </a:p>
           <a:p xmlns:a="http://schemas.openxmlformats.org/drawingml/2006/main">
@@ -1268,7 +2883,17 @@
           </a:p>
           <a:p xmlns:a="http://schemas.openxmlformats.org/drawingml/2006/main">
             <a:r>
-              <a:t>- 本页仅使用课程内部规则与教学材料。</a:t>
+              <a:t/>
+            </a:r>
+          </a:p>
+          <a:p xmlns:a="http://schemas.openxmlformats.org/drawingml/2006/main">
+            <a:r>
+              <a:t>- 本课 handout.md 与 slides.md</a:t>
+            </a:r>
+          </a:p>
+          <a:p xmlns:a="http://schemas.openxmlformats.org/drawingml/2006/main">
+            <a:r>
+              <a:t/>
             </a:r>
           </a:p>
           <a:p xmlns:a="http://schemas.openxmlformats.org/drawingml/2006/main">
@@ -1343,7 +2968,197 @@
           <a:lstStyle xmlns:a="http://schemas.openxmlformats.org/drawingml/2006/main"/>
           <a:p xmlns:a="http://schemas.openxmlformats.org/drawingml/2006/main">
             <a:r>
-              <a:t>页面标题：第 2 课之后，研究材料为何仍不可信</a:t>
+              <a:t>页面：P02 第 2 课之后，研究材料为何仍不可信</a:t>
+            </a:r>
+          </a:p>
+          <a:p xmlns:a="http://schemas.openxmlformats.org/drawingml/2006/main">
+            <a:r>
+              <a:t/>
+            </a:r>
+          </a:p>
+          <a:p xmlns:a="http://schemas.openxmlformats.org/drawingml/2006/main">
+            <a:r>
+              <a:t>讲义位置：本课讲义；见逐页母稿映射表</a:t>
+            </a:r>
+          </a:p>
+          <a:p xmlns:a="http://schemas.openxmlformats.org/drawingml/2006/main">
+            <a:r>
+              <a:t/>
+            </a:r>
+          </a:p>
+          <a:p xmlns:a="http://schemas.openxmlformats.org/drawingml/2006/main">
+            <a:r>
+              <a:t>屏显核对：</a:t>
+            </a:r>
+          </a:p>
+          <a:p xmlns:a="http://schemas.openxmlformats.org/drawingml/2006/main">
+            <a:r>
+              <a:t>第 2 课建立了：</a:t>
+            </a:r>
+          </a:p>
+          <a:p xmlns:a="http://schemas.openxmlformats.org/drawingml/2006/main">
+            <a:r>
+              <a:t>- 权限矩阵</a:t>
+            </a:r>
+          </a:p>
+          <a:p xmlns:a="http://schemas.openxmlformats.org/drawingml/2006/main">
+            <a:r>
+              <a:t>- AI 使用记录</a:t>
+            </a:r>
+          </a:p>
+          <a:p xmlns:a="http://schemas.openxmlformats.org/drawingml/2006/main">
+            <a:r>
+              <a:t>- 伦理清单</a:t>
+            </a:r>
+          </a:p>
+          <a:p xmlns:a="http://schemas.openxmlformats.org/drawingml/2006/main">
+            <a:r>
+              <a:t/>
+            </a:r>
+          </a:p>
+          <a:p xmlns:a="http://schemas.openxmlformats.org/drawingml/2006/main">
+            <a:r>
+              <a:t>仍未解决：</a:t>
+            </a:r>
+          </a:p>
+          <a:p xmlns:a="http://schemas.openxmlformats.org/drawingml/2006/main">
+            <a:r>
+              <a:t>- 论文是否真实存在？</a:t>
+            </a:r>
+          </a:p>
+          <a:p xmlns:a="http://schemas.openxmlformats.org/drawingml/2006/main">
+            <a:r>
+              <a:t>- AI 给出的题名、作者、DOI 是否一致？</a:t>
+            </a:r>
+          </a:p>
+          <a:p xmlns:a="http://schemas.openxmlformats.org/drawingml/2006/main">
+            <a:r>
+              <a:t>- 原文研究的任务和限定条件是什么？</a:t>
+            </a:r>
+          </a:p>
+          <a:p xmlns:a="http://schemas.openxmlformats.org/drawingml/2006/main">
+            <a:r>
+              <a:t/>
+            </a:r>
+          </a:p>
+          <a:p xmlns:a="http://schemas.openxmlformats.org/drawingml/2006/main">
+            <a:r>
+              <a:t>&gt; 权限和披露回答"AI 做过什么"，不回答"材料能不能信"。</a:t>
+            </a:r>
+          </a:p>
+          <a:p xmlns:a="http://schemas.openxmlformats.org/drawingml/2006/main">
+            <a:r>
+              <a:t/>
+            </a:r>
+          </a:p>
+          <a:p xmlns:a="http://schemas.openxmlformats.org/drawingml/2006/main">
+            <a:r>
+              <a:t>教师讲述：</a:t>
+            </a:r>
+          </a:p>
+          <a:p xmlns:a="http://schemas.openxmlformats.org/drawingml/2006/main">
+            <a:r>
+              <a:t>回扣第 2 课：受限交互让 AI 的动作可审计，但没有解决材料本身是否可信的问题。本课用可修改的问题初稿进入阶段四，处理“材料从哪来、可能支持什么”；八阶段是方法链，不是授课顺序。</a:t>
+            </a:r>
+          </a:p>
+          <a:p xmlns:a="http://schemas.openxmlformats.org/drawingml/2006/main">
+            <a:r>
+              <a:t/>
+            </a:r>
+          </a:p>
+          <a:p xmlns:a="http://schemas.openxmlformats.org/drawingml/2006/main">
+            <a:r>
+              <a:t>学生动作：</a:t>
+            </a:r>
+          </a:p>
+          <a:p xmlns:a="http://schemas.openxmlformats.org/drawingml/2006/main">
+            <a:r>
+              <a:t>快问：你最近一次把 AI 给出的引文直接搬进参考文献，是什么时候？只听回答，不评价。</a:t>
+            </a:r>
+          </a:p>
+          <a:p xmlns:a="http://schemas.openxmlformats.org/drawingml/2006/main">
+            <a:r>
+              <a:t/>
+            </a:r>
+          </a:p>
+          <a:p xmlns:a="http://schemas.openxmlformats.org/drawingml/2006/main">
+            <a:r>
+              <a:t>本课板书、诊断与串词：</a:t>
+            </a:r>
+          </a:p>
+          <a:p xmlns:a="http://schemas.openxmlformats.org/drawingml/2006/main">
+            <a:r>
+              <a:t>本节替换同类口头提示，不增加既有时段。开场诊断嵌入现有开场/回顾，后续再沿原实践时段操作。</a:t>
+            </a:r>
+          </a:p>
+          <a:p xmlns:a="http://schemas.openxmlformats.org/drawingml/2006/main">
+            <a:r>
+              <a:t/>
+            </a:r>
+          </a:p>
+          <a:p xmlns:a="http://schemas.openxmlformats.org/drawingml/2006/main">
+            <a:r>
+              <a:t>- **板书主线**：问题 → 检索式 → 命中 → 核验 → 纳入理由。</a:t>
+            </a:r>
+          </a:p>
+          <a:p xmlns:a="http://schemas.openxmlformats.org/drawingml/2006/main">
+            <a:r>
+              <a:t>- **诊断问题**：搜到记录，是否已经读到支持主张的原文？</a:t>
+            </a:r>
+          </a:p>
+          <a:p xmlns:a="http://schemas.openxmlformats.org/drawingml/2006/main">
+            <a:r>
+              <a:t>- **预期回答**：没有；先核验来源，再查与问题相关的原文。</a:t>
+            </a:r>
+          </a:p>
+          <a:p xmlns:a="http://schemas.openxmlformats.org/drawingml/2006/main">
+            <a:r>
+              <a:t>- **常见误答后的追问**：不强迫每人产生pending或rejected；按实际核验结果记录。</a:t>
+            </a:r>
+          </a:p>
+          <a:p xmlns:a="http://schemas.openxmlformats.org/drawingml/2006/main">
+            <a:r>
+              <a:t>- **过渡串词**：“记录真实筛选决定后，下一课才有值得精读的对象。”</a:t>
+            </a:r>
+          </a:p>
+          <a:p xmlns:a="http://schemas.openxmlformats.org/drawingml/2006/main">
+            <a:r>
+              <a:t>- **当堂最小产出**：一条可复盘检索和一个候选的实际核验状态。</a:t>
+            </a:r>
+          </a:p>
+          <a:p xmlns:a="http://schemas.openxmlformats.org/drawingml/2006/main">
+            <a:r>
+              <a:t>- **退出记录**：写“已完成的动作、本人项目仍缺的证据/工件、下次补齐位置”。使用教师包时标明课堂方法练习，不能据此宣称本人研究门通过；正式提交课次仍为第 6、9、13、16 课。</a:t>
+            </a:r>
+          </a:p>
+          <a:p xmlns:a="http://schemas.openxmlformats.org/drawingml/2006/main">
+            <a:r>
+              <a:t/>
+            </a:r>
+          </a:p>
+          <a:p xmlns:a="http://schemas.openxmlformats.org/drawingml/2006/main">
+            <a:r>
+              <a:t>来源与边界：</a:t>
+            </a:r>
+          </a:p>
+          <a:p xmlns:a="http://schemas.openxmlformats.org/drawingml/2006/main">
+            <a:r>
+              <a:t>回扣第 1-2 课讲义与 [AGENTS.md](../../AGENTS.md) 证据标准。</a:t>
+            </a:r>
+          </a:p>
+          <a:p xmlns:a="http://schemas.openxmlformats.org/drawingml/2006/main">
+            <a:r>
+              <a:t/>
+            </a:r>
+          </a:p>
+          <a:p xmlns:a="http://schemas.openxmlformats.org/drawingml/2006/main">
+            <a:r>
+              <a:t>---</a:t>
+            </a:r>
+          </a:p>
+          <a:p xmlns:a="http://schemas.openxmlformats.org/drawingml/2006/main">
+            <a:r>
+              <a:t/>
             </a:r>
           </a:p>
           <a:p xmlns:a="http://schemas.openxmlformats.org/drawingml/2006/main">
@@ -1353,7 +3168,17 @@
           </a:p>
           <a:p xmlns:a="http://schemas.openxmlformats.org/drawingml/2006/main">
             <a:r>
-              <a:t>- 本页仅使用课程内部规则与教学材料。</a:t>
+              <a:t/>
+            </a:r>
+          </a:p>
+          <a:p xmlns:a="http://schemas.openxmlformats.org/drawingml/2006/main">
+            <a:r>
+              <a:t>- 本课 handout.md 与 slides.md</a:t>
+            </a:r>
+          </a:p>
+          <a:p xmlns:a="http://schemas.openxmlformats.org/drawingml/2006/main">
+            <a:r>
+              <a:t/>
             </a:r>
           </a:p>
           <a:p xmlns:a="http://schemas.openxmlformats.org/drawingml/2006/main">
@@ -1428,7 +3253,137 @@
           <a:lstStyle xmlns:a="http://schemas.openxmlformats.org/drawingml/2006/main"/>
           <a:p xmlns:a="http://schemas.openxmlformats.org/drawingml/2006/main">
             <a:r>
-              <a:t>页面标题：本讲知识点总结：检索是证据入口</a:t>
+              <a:t>页面：P20 本讲知识点总结：检索是证据入口</a:t>
+            </a:r>
+          </a:p>
+          <a:p xmlns:a="http://schemas.openxmlformats.org/drawingml/2006/main">
+            <a:r>
+              <a:t/>
+            </a:r>
+          </a:p>
+          <a:p xmlns:a="http://schemas.openxmlformats.org/drawingml/2006/main">
+            <a:r>
+              <a:t>讲义位置：本课讲义；见逐页母稿映射表</a:t>
+            </a:r>
+          </a:p>
+          <a:p xmlns:a="http://schemas.openxmlformats.org/drawingml/2006/main">
+            <a:r>
+              <a:t/>
+            </a:r>
+          </a:p>
+          <a:p xmlns:a="http://schemas.openxmlformats.org/drawingml/2006/main">
+            <a:r>
+              <a:t>屏显核对：</a:t>
+            </a:r>
+          </a:p>
+          <a:p xmlns:a="http://schemas.openxmlformats.org/drawingml/2006/main">
+            <a:r>
+              <a:t>问题初稿 → 关键词／检索式 → 来源审计 → 候选文献表</a:t>
+            </a:r>
+          </a:p>
+          <a:p xmlns:a="http://schemas.openxmlformats.org/drawingml/2006/main">
+            <a:r>
+              <a:t/>
+            </a:r>
+          </a:p>
+          <a:p xmlns:a="http://schemas.openxmlformats.org/drawingml/2006/main">
+            <a:r>
+              <a:t>角色｜相对于问题或拟用主张：主证据／补充证据／对比证据／探索线索</a:t>
+            </a:r>
+          </a:p>
+          <a:p xmlns:a="http://schemas.openxmlformats.org/drawingml/2006/main">
+            <a:r>
+              <a:t/>
+            </a:r>
+          </a:p>
+          <a:p xmlns:a="http://schemas.openxmlformats.org/drawingml/2006/main">
+            <a:r>
+              <a:t>状态｜回原文裁定：`pending`／`verified`／`verified-with-caveat`／`rejected`</a:t>
+            </a:r>
+          </a:p>
+          <a:p xmlns:a="http://schemas.openxmlformats.org/drawingml/2006/main">
+            <a:r>
+              <a:t/>
+            </a:r>
+          </a:p>
+          <a:p xmlns:a="http://schemas.openxmlformats.org/drawingml/2006/main">
+            <a:r>
+              <a:t>决定｜人工记录：纳入／排除及理由；冲突证据保留</a:t>
+            </a:r>
+          </a:p>
+          <a:p xmlns:a="http://schemas.openxmlformats.org/drawingml/2006/main">
+            <a:r>
+              <a:t/>
+            </a:r>
+          </a:p>
+          <a:p xmlns:a="http://schemas.openxmlformats.org/drawingml/2006/main">
+            <a:r>
+              <a:t>&gt; AI 可以扩展、检索、整理和提出建议；学生确认问题、主张、角色与纳入决定。</a:t>
+            </a:r>
+          </a:p>
+          <a:p xmlns:a="http://schemas.openxmlformats.org/drawingml/2006/main">
+            <a:r>
+              <a:t/>
+            </a:r>
+          </a:p>
+          <a:p xmlns:a="http://schemas.openxmlformats.org/drawingml/2006/main">
+            <a:r>
+              <a:t>教师讲述：</a:t>
+            </a:r>
+          </a:p>
+          <a:p xmlns:a="http://schemas.openxmlformats.org/drawingml/2006/main">
+            <a:r>
+              <a:t>用 2.5 分钟复述一条主链和三个判断层次。强调“角色、状态、决定”不能合并：一篇文献可以身份已核验，但对当前主张仍只是探索线索；AI 可以提出四态和角色建议，最终确认与纳入理由由学生负责。</a:t>
+            </a:r>
+          </a:p>
+          <a:p xmlns:a="http://schemas.openxmlformats.org/drawingml/2006/main">
+            <a:r>
+              <a:t/>
+            </a:r>
+          </a:p>
+          <a:p xmlns:a="http://schemas.openxmlformats.org/drawingml/2006/main">
+            <a:r>
+              <a:t>学生动作：</a:t>
+            </a:r>
+          </a:p>
+          <a:p xmlns:a="http://schemas.openxmlformats.org/drawingml/2006/main">
+            <a:r>
+              <a:t>请学生对照自己的候选文献表，默检是否同时保留了角色、状态和决定三类字段；不现场新增正式提交。</a:t>
+            </a:r>
+          </a:p>
+          <a:p xmlns:a="http://schemas.openxmlformats.org/drawingml/2006/main">
+            <a:r>
+              <a:t/>
+            </a:r>
+          </a:p>
+          <a:p xmlns:a="http://schemas.openxmlformats.org/drawingml/2006/main">
+            <a:r>
+              <a:t>来源与边界：</a:t>
+            </a:r>
+          </a:p>
+          <a:p xmlns:a="http://schemas.openxmlformats.org/drawingml/2006/main">
+            <a:r>
+              <a:t>- 本页为讲义 §二至§五的方法汇总，不引入新事实；</a:t>
+            </a:r>
+          </a:p>
+          <a:p xmlns:a="http://schemas.openxmlformats.org/drawingml/2006/main">
+            <a:r>
+              <a:t>- AI 与人工边界以讲义 §二·5 和本课课堂产出要求为准。</a:t>
+            </a:r>
+          </a:p>
+          <a:p xmlns:a="http://schemas.openxmlformats.org/drawingml/2006/main">
+            <a:r>
+              <a:t/>
+            </a:r>
+          </a:p>
+          <a:p xmlns:a="http://schemas.openxmlformats.org/drawingml/2006/main">
+            <a:r>
+              <a:t>---</a:t>
+            </a:r>
+          </a:p>
+          <a:p xmlns:a="http://schemas.openxmlformats.org/drawingml/2006/main">
+            <a:r>
+              <a:t/>
             </a:r>
           </a:p>
           <a:p xmlns:a="http://schemas.openxmlformats.org/drawingml/2006/main">
@@ -1438,7 +3393,17 @@
           </a:p>
           <a:p xmlns:a="http://schemas.openxmlformats.org/drawingml/2006/main">
             <a:r>
-              <a:t>- 本页仅使用课程内部规则与教学材料。</a:t>
+              <a:t/>
+            </a:r>
+          </a:p>
+          <a:p xmlns:a="http://schemas.openxmlformats.org/drawingml/2006/main">
+            <a:r>
+              <a:t>- 本课 handout.md 与 slides.md</a:t>
+            </a:r>
+          </a:p>
+          <a:p xmlns:a="http://schemas.openxmlformats.org/drawingml/2006/main">
+            <a:r>
+              <a:t/>
             </a:r>
           </a:p>
           <a:p xmlns:a="http://schemas.openxmlformats.org/drawingml/2006/main">
@@ -1513,7 +3478,177 @@
           <a:lstStyle xmlns:a="http://schemas.openxmlformats.org/drawingml/2006/main"/>
           <a:p xmlns:a="http://schemas.openxmlformats.org/drawingml/2006/main">
             <a:r>
-              <a:t>页面标题：退出卡与第 4 课预告</a:t>
+              <a:t>页面：P21 退出卡与第 4 课预告</a:t>
+            </a:r>
+          </a:p>
+          <a:p xmlns:a="http://schemas.openxmlformats.org/drawingml/2006/main">
+            <a:r>
+              <a:t/>
+            </a:r>
+          </a:p>
+          <a:p xmlns:a="http://schemas.openxmlformats.org/drawingml/2006/main">
+            <a:r>
+              <a:t>讲义位置：本课讲义；见逐页母稿映射表</a:t>
+            </a:r>
+          </a:p>
+          <a:p xmlns:a="http://schemas.openxmlformats.org/drawingml/2006/main">
+            <a:r>
+              <a:t/>
+            </a:r>
+          </a:p>
+          <a:p xmlns:a="http://schemas.openxmlformats.org/drawingml/2006/main">
+            <a:r>
+              <a:t>屏显核对：</a:t>
+            </a:r>
+          </a:p>
+          <a:p xmlns:a="http://schemas.openxmlformats.org/drawingml/2006/main">
+            <a:r>
+              <a:t>退出卡：</a:t>
+            </a:r>
+          </a:p>
+          <a:p xmlns:a="http://schemas.openxmlformats.org/drawingml/2006/main">
+            <a:r>
+              <a:t>- 今天最清楚的一点；</a:t>
+            </a:r>
+          </a:p>
+          <a:p xmlns:a="http://schemas.openxmlformats.org/drawingml/2006/main">
+            <a:r>
+              <a:t>- 仍然困惑的一点；</a:t>
+            </a:r>
+          </a:p>
+          <a:p xmlns:a="http://schemas.openxmlformats.org/drawingml/2006/main">
+            <a:r>
+              <a:t>- 检索过程是否可复盘；</a:t>
+            </a:r>
+          </a:p>
+          <a:p xmlns:a="http://schemas.openxmlformats.org/drawingml/2006/main">
+            <a:r>
+              <a:t>- 候选文献表当前 verified 条数；</a:t>
+            </a:r>
+          </a:p>
+          <a:p xmlns:a="http://schemas.openxmlformats.org/drawingml/2006/main">
+            <a:r>
+              <a:t>- 第 4 课需要补的精读案例。</a:t>
+            </a:r>
+          </a:p>
+          <a:p xmlns:a="http://schemas.openxmlformats.org/drawingml/2006/main">
+            <a:r>
+              <a:t/>
+            </a:r>
+          </a:p>
+          <a:p xmlns:a="http://schemas.openxmlformats.org/drawingml/2006/main">
+            <a:r>
+              <a:t>第 4 课预告：AI 辅助论文精读与主张核验</a:t>
+            </a:r>
+          </a:p>
+          <a:p xmlns:a="http://schemas.openxmlformats.org/drawingml/2006/main">
+            <a:r>
+              <a:t/>
+            </a:r>
+          </a:p>
+          <a:p xmlns:a="http://schemas.openxmlformats.org/drawingml/2006/main">
+            <a:r>
+              <a:t>&gt; 不新增课后正式作业。持续回写到第 6 课问题门。</a:t>
+            </a:r>
+          </a:p>
+          <a:p xmlns:a="http://schemas.openxmlformats.org/drawingml/2006/main">
+            <a:r>
+              <a:t/>
+            </a:r>
+          </a:p>
+          <a:p xmlns:a="http://schemas.openxmlformats.org/drawingml/2006/main">
+            <a:r>
+              <a:t>教师讲述：</a:t>
+            </a:r>
+          </a:p>
+          <a:p xmlns:a="http://schemas.openxmlformats.org/drawingml/2006/main">
+            <a:r>
+              <a:t>回扣本课目标：学生不需要在 90 分钟内完成文献综述，只要项目里有检索记录、候选文献表第一版、证据角色初标和一条 AI 使用记录，就已经形成可继续检查的起点。</a:t>
+            </a:r>
+          </a:p>
+          <a:p xmlns:a="http://schemas.openxmlformats.org/drawingml/2006/main">
+            <a:r>
+              <a:t/>
+            </a:r>
+          </a:p>
+          <a:p xmlns:a="http://schemas.openxmlformats.org/drawingml/2006/main">
+            <a:r>
+              <a:t>课后引导阅读（采用 AI 导航→原文核验→AI 质疑→偏差审计→人工定稿流程）：</a:t>
+            </a:r>
+          </a:p>
+          <a:p xmlns:a="http://schemas.openxmlformats.org/drawingml/2006/main">
+            <a:r>
+              <a:t>- Booth et al. *The Craft of Research*, 5th ed., Chapter 3，约 30 分钟，核心阅读；</a:t>
+            </a:r>
+          </a:p>
+          <a:p xmlns:a="http://schemas.openxmlformats.org/drawingml/2006/main">
+            <a:r>
+              <a:t>- Kitchenham &amp; Charters SLR guidelines 选段，任选，约 25 分钟；</a:t>
+            </a:r>
+          </a:p>
+          <a:p xmlns:a="http://schemas.openxmlformats.org/drawingml/2006/main">
+            <a:r>
+              <a:t>- PRISMA 2020 checklist 与 flow diagram，任选，约 15 分钟。</a:t>
+            </a:r>
+          </a:p>
+          <a:p xmlns:a="http://schemas.openxmlformats.org/drawingml/2006/main">
+            <a:r>
+              <a:t/>
+            </a:r>
+          </a:p>
+          <a:p xmlns:a="http://schemas.openxmlformats.org/drawingml/2006/main">
+            <a:r>
+              <a:t>阅读卡持续保存在个人项目 `notes/`，不逐周正式提交。</a:t>
+            </a:r>
+          </a:p>
+          <a:p xmlns:a="http://schemas.openxmlformats.org/drawingml/2006/main">
+            <a:r>
+              <a:t/>
+            </a:r>
+          </a:p>
+          <a:p xmlns:a="http://schemas.openxmlformats.org/drawingml/2006/main">
+            <a:r>
+              <a:t>学生动作：</a:t>
+            </a:r>
+          </a:p>
+          <a:p xmlns:a="http://schemas.openxmlformats.org/drawingml/2006/main">
+            <a:r>
+              <a:t>学生提交退出卡或保存在个人项目。教师收集共性问题，用于第 4 课前调整。</a:t>
+            </a:r>
+          </a:p>
+          <a:p xmlns:a="http://schemas.openxmlformats.org/drawingml/2006/main">
+            <a:r>
+              <a:t/>
+            </a:r>
+          </a:p>
+          <a:p xmlns:a="http://schemas.openxmlformats.org/drawingml/2006/main">
+            <a:r>
+              <a:t>来源与边界：</a:t>
+            </a:r>
+          </a:p>
+          <a:p xmlns:a="http://schemas.openxmlformats.org/drawingml/2006/main">
+            <a:r>
+              <a:t>- Booth, W. C. et al. *The Craft of Research*, 5th ed. [出版社页面](https://press.uchicago.edu/ucp/books/book/chicago/C/bo215874008)。</a:t>
+            </a:r>
+          </a:p>
+          <a:p xmlns:a="http://schemas.openxmlformats.org/drawingml/2006/main">
+            <a:r>
+              <a:t>- Kitchenham, B., &amp; Charters, S. EBSE-2007-01, 2007. [机构索引](https://ebse.webspace.durham.ac.uk/ebse-bibliography/guidelines-for-performing-systematic-literature-reviews-in-software-engineering/)。</a:t>
+            </a:r>
+          </a:p>
+          <a:p xmlns:a="http://schemas.openxmlformats.org/drawingml/2006/main">
+            <a:r>
+              <a:t>- Page, M. J. et al. *BMJ* 372:n71 (2021). DOI: [10.1136/bmj.n71](https://www.bmj.com/content/372/bmj.n71)。</a:t>
+            </a:r>
+          </a:p>
+          <a:p xmlns:a="http://schemas.openxmlformats.org/drawingml/2006/main">
+            <a:r>
+              <a:t>- 阅读规则见 [reading-list.md](../../course/reading-list.md)。</a:t>
+            </a:r>
+          </a:p>
+          <a:p xmlns:a="http://schemas.openxmlformats.org/drawingml/2006/main">
+            <a:r>
+              <a:t/>
             </a:r>
           </a:p>
           <a:p xmlns:a="http://schemas.openxmlformats.org/drawingml/2006/main">
@@ -1523,7 +3658,17 @@
           </a:p>
           <a:p xmlns:a="http://schemas.openxmlformats.org/drawingml/2006/main">
             <a:r>
-              <a:t>- 本页仅使用课程内部规则与教学材料。</a:t>
+              <a:t/>
+            </a:r>
+          </a:p>
+          <a:p xmlns:a="http://schemas.openxmlformats.org/drawingml/2006/main">
+            <a:r>
+              <a:t>- 本课 handout.md 与 slides.md</a:t>
+            </a:r>
+          </a:p>
+          <a:p xmlns:a="http://schemas.openxmlformats.org/drawingml/2006/main">
+            <a:r>
+              <a:t/>
             </a:r>
           </a:p>
           <a:p xmlns:a="http://schemas.openxmlformats.org/drawingml/2006/main">
@@ -1598,7 +3743,137 @@
           <a:lstStyle xmlns:a="http://schemas.openxmlformats.org/drawingml/2006/main"/>
           <a:p xmlns:a="http://schemas.openxmlformats.org/drawingml/2006/main">
             <a:r>
-              <a:t>页面标题：本课目标与课堂产出</a:t>
+              <a:t>页面：P03 本课目标与课堂产出</a:t>
+            </a:r>
+          </a:p>
+          <a:p xmlns:a="http://schemas.openxmlformats.org/drawingml/2006/main">
+            <a:r>
+              <a:t/>
+            </a:r>
+          </a:p>
+          <a:p xmlns:a="http://schemas.openxmlformats.org/drawingml/2006/main">
+            <a:r>
+              <a:t>讲义位置：本课讲义；见逐页母稿映射表</a:t>
+            </a:r>
+          </a:p>
+          <a:p xmlns:a="http://schemas.openxmlformats.org/drawingml/2006/main">
+            <a:r>
+              <a:t/>
+            </a:r>
+          </a:p>
+          <a:p xmlns:a="http://schemas.openxmlformats.org/drawingml/2006/main">
+            <a:r>
+              <a:t>屏显核对：</a:t>
+            </a:r>
+          </a:p>
+          <a:p xmlns:a="http://schemas.openxmlformats.org/drawingml/2006/main">
+            <a:r>
+              <a:t>完成本课后，你能：</a:t>
+            </a:r>
+          </a:p>
+          <a:p xmlns:a="http://schemas.openxmlformats.org/drawingml/2006/main">
+            <a:r>
+              <a:t/>
+            </a:r>
+          </a:p>
+          <a:p xmlns:a="http://schemas.openxmlformats.org/drawingml/2006/main">
+            <a:r>
+              <a:t>1. 从问题生成可复盘的关键词、检索式和纳入/排除条件；</a:t>
+            </a:r>
+          </a:p>
+          <a:p xmlns:a="http://schemas.openxmlformats.org/drawingml/2006/main">
+            <a:r>
+              <a:t>2. 区分主证据、补充证据、对比证据与探索线索；</a:t>
+            </a:r>
+          </a:p>
+          <a:p xmlns:a="http://schemas.openxmlformats.org/drawingml/2006/main">
+            <a:r>
+              <a:t>3. 对 AI 检索结果执行回原文核验；</a:t>
+            </a:r>
+          </a:p>
+          <a:p xmlns:a="http://schemas.openxmlformats.org/drawingml/2006/main">
+            <a:r>
+              <a:t>4. 建立候选文献表第一版。</a:t>
+            </a:r>
+          </a:p>
+          <a:p xmlns:a="http://schemas.openxmlformats.org/drawingml/2006/main">
+            <a:r>
+              <a:t/>
+            </a:r>
+          </a:p>
+          <a:p xmlns:a="http://schemas.openxmlformats.org/drawingml/2006/main">
+            <a:r>
+              <a:t>课堂产出：1 条检索记录 + 2 条审计 + 1 条已核验候选记录 + 证据角色初标</a:t>
+            </a:r>
+          </a:p>
+          <a:p xmlns:a="http://schemas.openxmlformats.org/drawingml/2006/main">
+            <a:r>
+              <a:t/>
+            </a:r>
+          </a:p>
+          <a:p xmlns:a="http://schemas.openxmlformats.org/drawingml/2006/main">
+            <a:r>
+              <a:t>&gt; 本课不正式提交，第 6 课问题门统一检查。</a:t>
+            </a:r>
+          </a:p>
+          <a:p xmlns:a="http://schemas.openxmlformats.org/drawingml/2006/main">
+            <a:r>
+              <a:t/>
+            </a:r>
+          </a:p>
+          <a:p xmlns:a="http://schemas.openxmlformats.org/drawingml/2006/main">
+            <a:r>
+              <a:t>教师讲述：</a:t>
+            </a:r>
+          </a:p>
+          <a:p xmlns:a="http://schemas.openxmlformats.org/drawingml/2006/main">
+            <a:r>
+              <a:t>明确边界：本课目标是建立可复盘的检索过程，不是完成文献综述。27 分钟内只要求 1 条完整检索记录、2 条审计、1 条已核验候选记录和 1 条 AI 记录。</a:t>
+            </a:r>
+          </a:p>
+          <a:p xmlns:a="http://schemas.openxmlformats.org/drawingml/2006/main">
+            <a:r>
+              <a:t/>
+            </a:r>
+          </a:p>
+          <a:p xmlns:a="http://schemas.openxmlformats.org/drawingml/2006/main">
+            <a:r>
+              <a:t>学生动作：</a:t>
+            </a:r>
+          </a:p>
+          <a:p xmlns:a="http://schemas.openxmlformats.org/drawingml/2006/main">
+            <a:r>
+              <a:t>无。</a:t>
+            </a:r>
+          </a:p>
+          <a:p xmlns:a="http://schemas.openxmlformats.org/drawingml/2006/main">
+            <a:r>
+              <a:t/>
+            </a:r>
+          </a:p>
+          <a:p xmlns:a="http://schemas.openxmlformats.org/drawingml/2006/main">
+            <a:r>
+              <a:t>来源与边界：</a:t>
+            </a:r>
+          </a:p>
+          <a:p xmlns:a="http://schemas.openxmlformats.org/drawingml/2006/main">
+            <a:r>
+              <a:t>[备课规划.md](../备课规划.md) 第 3 课目标段；[assignments.md](../../course/assignments.md) 研究门条件。</a:t>
+            </a:r>
+          </a:p>
+          <a:p xmlns:a="http://schemas.openxmlformats.org/drawingml/2006/main">
+            <a:r>
+              <a:t/>
+            </a:r>
+          </a:p>
+          <a:p xmlns:a="http://schemas.openxmlformats.org/drawingml/2006/main">
+            <a:r>
+              <a:t>---</a:t>
+            </a:r>
+          </a:p>
+          <a:p xmlns:a="http://schemas.openxmlformats.org/drawingml/2006/main">
+            <a:r>
+              <a:t/>
             </a:r>
           </a:p>
           <a:p xmlns:a="http://schemas.openxmlformats.org/drawingml/2006/main">
@@ -1608,7 +3883,17 @@
           </a:p>
           <a:p xmlns:a="http://schemas.openxmlformats.org/drawingml/2006/main">
             <a:r>
-              <a:t>- 本页仅使用课程内部规则与教学材料。</a:t>
+              <a:t/>
+            </a:r>
+          </a:p>
+          <a:p xmlns:a="http://schemas.openxmlformats.org/drawingml/2006/main">
+            <a:r>
+              <a:t>- 本课 handout.md 与 slides.md</a:t>
+            </a:r>
+          </a:p>
+          <a:p xmlns:a="http://schemas.openxmlformats.org/drawingml/2006/main">
+            <a:r>
+              <a:t/>
             </a:r>
           </a:p>
           <a:p xmlns:a="http://schemas.openxmlformats.org/drawingml/2006/main">
@@ -1683,7 +3968,122 @@
           <a:lstStyle xmlns:a="http://schemas.openxmlformats.org/drawingml/2006/main"/>
           <a:p xmlns:a="http://schemas.openxmlformats.org/drawingml/2006/main">
             <a:r>
-              <a:t>页面标题：搜得多不等于证据充分</a:t>
+              <a:t>页面：P04 搜得多不等于证据充分</a:t>
+            </a:r>
+          </a:p>
+          <a:p xmlns:a="http://schemas.openxmlformats.org/drawingml/2006/main">
+            <a:r>
+              <a:t/>
+            </a:r>
+          </a:p>
+          <a:p xmlns:a="http://schemas.openxmlformats.org/drawingml/2006/main">
+            <a:r>
+              <a:t>讲义位置：本课讲义；见逐页母稿映射表</a:t>
+            </a:r>
+          </a:p>
+          <a:p xmlns:a="http://schemas.openxmlformats.org/drawingml/2006/main">
+            <a:r>
+              <a:t/>
+            </a:r>
+          </a:p>
+          <a:p xmlns:a="http://schemas.openxmlformats.org/drawingml/2006/main">
+            <a:r>
+              <a:t>屏显核对：</a:t>
+            </a:r>
+          </a:p>
+          <a:p xmlns:a="http://schemas.openxmlformats.org/drawingml/2006/main">
+            <a:r>
+              <a:t>常见失败：</a:t>
+            </a:r>
+          </a:p>
+          <a:p xmlns:a="http://schemas.openxmlformats.org/drawingml/2006/main">
+            <a:r>
+              <a:t>- 50 篇论文都标"主证据"</a:t>
+            </a:r>
+          </a:p>
+          <a:p xmlns:a="http://schemas.openxmlformats.org/drawingml/2006/main">
+            <a:r>
+              <a:t>- AI 报告引文直接进参考文献</a:t>
+            </a:r>
+          </a:p>
+          <a:p xmlns:a="http://schemas.openxmlformats.org/drawingml/2006/main">
+            <a:r>
+              <a:t>- 反例被悄悄排除</a:t>
+            </a:r>
+          </a:p>
+          <a:p xmlns:a="http://schemas.openxmlformats.org/drawingml/2006/main">
+            <a:r>
+              <a:t>- 检索式不记录，无法复盘</a:t>
+            </a:r>
+          </a:p>
+          <a:p xmlns:a="http://schemas.openxmlformats.org/drawingml/2006/main">
+            <a:r>
+              <a:t/>
+            </a:r>
+          </a:p>
+          <a:p xmlns:a="http://schemas.openxmlformats.org/drawingml/2006/main">
+            <a:r>
+              <a:t>&gt; 数量不产生充分性；角色清晰和独立性才产生。</a:t>
+            </a:r>
+          </a:p>
+          <a:p xmlns:a="http://schemas.openxmlformats.org/drawingml/2006/main">
+            <a:r>
+              <a:t/>
+            </a:r>
+          </a:p>
+          <a:p xmlns:a="http://schemas.openxmlformats.org/drawingml/2006/main">
+            <a:r>
+              <a:t>教师讲述：</a:t>
+            </a:r>
+          </a:p>
+          <a:p xmlns:a="http://schemas.openxmlformats.org/drawingml/2006/main">
+            <a:r>
+              <a:t>来看几个常见错误。证据充分性来自角色清晰和独立性，不是数量。下面几页来看怎样从问题出发构造可复盘的检索过程。</a:t>
+            </a:r>
+          </a:p>
+          <a:p xmlns:a="http://schemas.openxmlformats.org/drawingml/2006/main">
+            <a:r>
+              <a:t/>
+            </a:r>
+          </a:p>
+          <a:p xmlns:a="http://schemas.openxmlformats.org/drawingml/2006/main">
+            <a:r>
+              <a:t>学生动作：</a:t>
+            </a:r>
+          </a:p>
+          <a:p xmlns:a="http://schemas.openxmlformats.org/drawingml/2006/main">
+            <a:r>
+              <a:t>请学生举手：你是否曾经把 AI 综述的引文直接复制进参考文献？只统计，不点名。</a:t>
+            </a:r>
+          </a:p>
+          <a:p xmlns:a="http://schemas.openxmlformats.org/drawingml/2006/main">
+            <a:r>
+              <a:t/>
+            </a:r>
+          </a:p>
+          <a:p xmlns:a="http://schemas.openxmlformats.org/drawingml/2006/main">
+            <a:r>
+              <a:t>来源与边界：</a:t>
+            </a:r>
+          </a:p>
+          <a:p xmlns:a="http://schemas.openxmlformats.org/drawingml/2006/main">
+            <a:r>
+              <a:t>[AGENTS.md](../../AGENTS.md) 证据标准；[syllabus.md](../../course/syllabus.md) 教学原则。</a:t>
+            </a:r>
+          </a:p>
+          <a:p xmlns:a="http://schemas.openxmlformats.org/drawingml/2006/main">
+            <a:r>
+              <a:t/>
+            </a:r>
+          </a:p>
+          <a:p xmlns:a="http://schemas.openxmlformats.org/drawingml/2006/main">
+            <a:r>
+              <a:t>---</a:t>
+            </a:r>
+          </a:p>
+          <a:p xmlns:a="http://schemas.openxmlformats.org/drawingml/2006/main">
+            <a:r>
+              <a:t/>
             </a:r>
           </a:p>
           <a:p xmlns:a="http://schemas.openxmlformats.org/drawingml/2006/main">
@@ -1693,7 +4093,17 @@
           </a:p>
           <a:p xmlns:a="http://schemas.openxmlformats.org/drawingml/2006/main">
             <a:r>
-              <a:t>- 本页仅使用课程内部规则与教学材料。</a:t>
+              <a:t/>
+            </a:r>
+          </a:p>
+          <a:p xmlns:a="http://schemas.openxmlformats.org/drawingml/2006/main">
+            <a:r>
+              <a:t>- 本课 handout.md 与 slides.md</a:t>
+            </a:r>
+          </a:p>
+          <a:p xmlns:a="http://schemas.openxmlformats.org/drawingml/2006/main">
+            <a:r>
+              <a:t/>
             </a:r>
           </a:p>
           <a:p xmlns:a="http://schemas.openxmlformats.org/drawingml/2006/main">
@@ -1768,7 +4178,142 @@
           <a:lstStyle xmlns:a="http://schemas.openxmlformats.org/drawingml/2006/main"/>
           <a:p xmlns:a="http://schemas.openxmlformats.org/drawingml/2006/main">
             <a:r>
-              <a:t>页面标题：外部输入不止论文</a:t>
+              <a:t>页面：P05 外部输入不止论文</a:t>
+            </a:r>
+          </a:p>
+          <a:p xmlns:a="http://schemas.openxmlformats.org/drawingml/2006/main">
+            <a:r>
+              <a:t/>
+            </a:r>
+          </a:p>
+          <a:p xmlns:a="http://schemas.openxmlformats.org/drawingml/2006/main">
+            <a:r>
+              <a:t>讲义位置：本课讲义；见逐页母稿映射表</a:t>
+            </a:r>
+          </a:p>
+          <a:p xmlns:a="http://schemas.openxmlformats.org/drawingml/2006/main">
+            <a:r>
+              <a:t/>
+            </a:r>
+          </a:p>
+          <a:p xmlns:a="http://schemas.openxmlformats.org/drawingml/2006/main">
+            <a:r>
+              <a:t>屏显核对：</a:t>
+            </a:r>
+          </a:p>
+          <a:p xmlns:a="http://schemas.openxmlformats.org/drawingml/2006/main">
+            <a:r>
+              <a:t>| 类型 | 例子 | 用途／核验重点 |</a:t>
+            </a:r>
+          </a:p>
+          <a:p xmlns:a="http://schemas.openxmlformats.org/drawingml/2006/main">
+            <a:r>
+              <a:t>| --- | --- | --- |</a:t>
+            </a:r>
+          </a:p>
+          <a:p xmlns:a="http://schemas.openxmlformats.org/drawingml/2006/main">
+            <a:r>
+              <a:t>| 同行评议论文 | 期刊、会议 | 任务、设置、主张、限定 |</a:t>
+            </a:r>
+          </a:p>
+          <a:p xmlns:a="http://schemas.openxmlformats.org/drawingml/2006/main">
+            <a:r>
+              <a:t>| 经典书籍选章 | 方法论、统计 | 版本、章节、适用范围 |</a:t>
+            </a:r>
+          </a:p>
+          <a:p xmlns:a="http://schemas.openxmlformats.org/drawingml/2006/main">
+            <a:r>
+              <a:t>| 正式规范 | PRISMA、ACM Badging | 发布机构、版本、对象 |</a:t>
+            </a:r>
+          </a:p>
+          <a:p xmlns:a="http://schemas.openxmlformats.org/drawingml/2006/main">
+            <a:r>
+              <a:t>| 代码与数据集 | GitHub、数据卡片 | 身份、commit、许可、版本 |</a:t>
+            </a:r>
+          </a:p>
+          <a:p xmlns:a="http://schemas.openxmlformats.org/drawingml/2006/main">
+            <a:r>
+              <a:t>| 官方文档 | 协议、API | 官方身份、版本、时效 |</a:t>
+            </a:r>
+          </a:p>
+          <a:p xmlns:a="http://schemas.openxmlformats.org/drawingml/2006/main">
+            <a:r>
+              <a:t>| 工程文章、issue | 厂商文、失败记录 | 主体、上下文、可追溯性 |</a:t>
+            </a:r>
+          </a:p>
+          <a:p xmlns:a="http://schemas.openxmlformats.org/drawingml/2006/main">
+            <a:r>
+              <a:t>| AI 搜索结果 | 模型候选列表 | 仅作发现线索，回正式来源 |</a:t>
+            </a:r>
+          </a:p>
+          <a:p xmlns:a="http://schemas.openxmlformats.org/drawingml/2006/main">
+            <a:r>
+              <a:t/>
+            </a:r>
+          </a:p>
+          <a:p xmlns:a="http://schemas.openxmlformats.org/drawingml/2006/main">
+            <a:r>
+              <a:t>&gt; 来源类型不自动决定可信度或证据角色；角色要相对于当前问题或拟用主张判断。</a:t>
+            </a:r>
+          </a:p>
+          <a:p xmlns:a="http://schemas.openxmlformats.org/drawingml/2006/main">
+            <a:r>
+              <a:t/>
+            </a:r>
+          </a:p>
+          <a:p xmlns:a="http://schemas.openxmlformats.org/drawingml/2006/main">
+            <a:r>
+              <a:t>教师讲述：</a:t>
+            </a:r>
+          </a:p>
+          <a:p xmlns:a="http://schemas.openxmlformats.org/drawingml/2006/main">
+            <a:r>
+              <a:t>不要把所有材料混同。来源类型本身不决定可信度，但正式来源优先于转载和二手材料。AI 给出的题名、作者、DOI 必须回到正式来源核验，未核验前只能算探索线索。</a:t>
+            </a:r>
+          </a:p>
+          <a:p xmlns:a="http://schemas.openxmlformats.org/drawingml/2006/main">
+            <a:r>
+              <a:t/>
+            </a:r>
+          </a:p>
+          <a:p xmlns:a="http://schemas.openxmlformats.org/drawingml/2006/main">
+            <a:r>
+              <a:t>学生动作：</a:t>
+            </a:r>
+          </a:p>
+          <a:p xmlns:a="http://schemas.openxmlformats.org/drawingml/2006/main">
+            <a:r>
+              <a:t>让学生指出：你项目里目前哪类材料最多？哪类最缺？</a:t>
+            </a:r>
+          </a:p>
+          <a:p xmlns:a="http://schemas.openxmlformats.org/drawingml/2006/main">
+            <a:r>
+              <a:t/>
+            </a:r>
+          </a:p>
+          <a:p xmlns:a="http://schemas.openxmlformats.org/drawingml/2006/main">
+            <a:r>
+              <a:t>来源与边界：</a:t>
+            </a:r>
+          </a:p>
+          <a:p xmlns:a="http://schemas.openxmlformats.org/drawingml/2006/main">
+            <a:r>
+              <a:t>讲义 §一 外部输入类型表；[reading-list.md](../../course/reading-list.md) 书目层级。</a:t>
+            </a:r>
+          </a:p>
+          <a:p xmlns:a="http://schemas.openxmlformats.org/drawingml/2006/main">
+            <a:r>
+              <a:t/>
+            </a:r>
+          </a:p>
+          <a:p xmlns:a="http://schemas.openxmlformats.org/drawingml/2006/main">
+            <a:r>
+              <a:t>---</a:t>
+            </a:r>
+          </a:p>
+          <a:p xmlns:a="http://schemas.openxmlformats.org/drawingml/2006/main">
+            <a:r>
+              <a:t/>
             </a:r>
           </a:p>
           <a:p xmlns:a="http://schemas.openxmlformats.org/drawingml/2006/main">
@@ -1778,7 +4323,17 @@
           </a:p>
           <a:p xmlns:a="http://schemas.openxmlformats.org/drawingml/2006/main">
             <a:r>
-              <a:t>- 本页仅使用课程内部规则与教学材料。</a:t>
+              <a:t/>
+            </a:r>
+          </a:p>
+          <a:p xmlns:a="http://schemas.openxmlformats.org/drawingml/2006/main">
+            <a:r>
+              <a:t>- 本课 handout.md 与 slides.md</a:t>
+            </a:r>
+          </a:p>
+          <a:p xmlns:a="http://schemas.openxmlformats.org/drawingml/2006/main">
+            <a:r>
+              <a:t/>
             </a:r>
           </a:p>
           <a:p xmlns:a="http://schemas.openxmlformats.org/drawingml/2006/main">
@@ -1853,7 +4408,127 @@
           <a:lstStyle xmlns:a="http://schemas.openxmlformats.org/drawingml/2006/main"/>
           <a:p xmlns:a="http://schemas.openxmlformats.org/drawingml/2006/main">
             <a:r>
-              <a:t>页面标题：先写问题，再搜材料</a:t>
+              <a:t>页面：P06 先写问题，再搜材料</a:t>
+            </a:r>
+          </a:p>
+          <a:p xmlns:a="http://schemas.openxmlformats.org/drawingml/2006/main">
+            <a:r>
+              <a:t/>
+            </a:r>
+          </a:p>
+          <a:p xmlns:a="http://schemas.openxmlformats.org/drawingml/2006/main">
+            <a:r>
+              <a:t>讲义位置：本课讲义；见逐页母稿映射表</a:t>
+            </a:r>
+          </a:p>
+          <a:p xmlns:a="http://schemas.openxmlformats.org/drawingml/2006/main">
+            <a:r>
+              <a:t/>
+            </a:r>
+          </a:p>
+          <a:p xmlns:a="http://schemas.openxmlformats.org/drawingml/2006/main">
+            <a:r>
+              <a:t>屏显核对：</a:t>
+            </a:r>
+          </a:p>
+          <a:p xmlns:a="http://schemas.openxmlformats.org/drawingml/2006/main">
+            <a:r>
+              <a:t>宽泛主题：AI 辅助论文阅读</a:t>
+            </a:r>
+          </a:p>
+          <a:p xmlns:a="http://schemas.openxmlformats.org/drawingml/2006/main">
+            <a:r>
+              <a:t/>
+            </a:r>
+          </a:p>
+          <a:p xmlns:a="http://schemas.openxmlformats.org/drawingml/2006/main">
+            <a:r>
+              <a:t>可检索的问题初稿：</a:t>
+            </a:r>
+          </a:p>
+          <a:p xmlns:a="http://schemas.openxmlformats.org/drawingml/2006/main">
+            <a:r>
+              <a:t>&gt; 在需要逐条核验引用的计算机论文阅读任务中，结构化阅读卡是否降低 AI 摘要的限定条件遗漏率？</a:t>
+            </a:r>
+          </a:p>
+          <a:p xmlns:a="http://schemas.openxmlformats.org/drawingml/2006/main">
+            <a:r>
+              <a:t/>
+            </a:r>
+          </a:p>
+          <a:p xmlns:a="http://schemas.openxmlformats.org/drawingml/2006/main">
+            <a:r>
+              <a:t>抽词：结构化阅读卡｜AI 摘要｜限定条件｜遗漏率｜引用核验</a:t>
+            </a:r>
+          </a:p>
+          <a:p xmlns:a="http://schemas.openxmlformats.org/drawingml/2006/main">
+            <a:r>
+              <a:t/>
+            </a:r>
+          </a:p>
+          <a:p xmlns:a="http://schemas.openxmlformats.org/drawingml/2006/main">
+            <a:r>
+              <a:t>每个词扩展同义、上位、下位 → 检索词网</a:t>
+            </a:r>
+          </a:p>
+          <a:p xmlns:a="http://schemas.openxmlformats.org/drawingml/2006/main">
+            <a:r>
+              <a:t/>
+            </a:r>
+          </a:p>
+          <a:p xmlns:a="http://schemas.openxmlformats.org/drawingml/2006/main">
+            <a:r>
+              <a:t>教师讲述：</a:t>
+            </a:r>
+          </a:p>
+          <a:p xmlns:a="http://schemas.openxmlformats.org/drawingml/2006/main">
+            <a:r>
+              <a:t>最常见的错误是带着主题词直接搜。这里的问题只是驱动第一轮检索的初稿，第 6 课再系统定稿；检索结果可以回写问题和关键词。问题给出对象、干预、比较和指标，每个部分对应可检索词。</a:t>
+            </a:r>
+          </a:p>
+          <a:p xmlns:a="http://schemas.openxmlformats.org/drawingml/2006/main">
+            <a:r>
+              <a:t/>
+            </a:r>
+          </a:p>
+          <a:p xmlns:a="http://schemas.openxmlformats.org/drawingml/2006/main">
+            <a:r>
+              <a:t>学生动作：</a:t>
+            </a:r>
+          </a:p>
+          <a:p xmlns:a="http://schemas.openxmlformats.org/drawingml/2006/main">
+            <a:r>
+              <a:t>请学生用自己的问题抽 3 个关键词，并说出一个同义词。</a:t>
+            </a:r>
+          </a:p>
+          <a:p xmlns:a="http://schemas.openxmlformats.org/drawingml/2006/main">
+            <a:r>
+              <a:t/>
+            </a:r>
+          </a:p>
+          <a:p xmlns:a="http://schemas.openxmlformats.org/drawingml/2006/main">
+            <a:r>
+              <a:t>来源与边界：</a:t>
+            </a:r>
+          </a:p>
+          <a:p xmlns:a="http://schemas.openxmlformats.org/drawingml/2006/main">
+            <a:r>
+              <a:t>贯穿案例来自第 1 课 handout；不预设结论。</a:t>
+            </a:r>
+          </a:p>
+          <a:p xmlns:a="http://schemas.openxmlformats.org/drawingml/2006/main">
+            <a:r>
+              <a:t/>
+            </a:r>
+          </a:p>
+          <a:p xmlns:a="http://schemas.openxmlformats.org/drawingml/2006/main">
+            <a:r>
+              <a:t>---</a:t>
+            </a:r>
+          </a:p>
+          <a:p xmlns:a="http://schemas.openxmlformats.org/drawingml/2006/main">
+            <a:r>
+              <a:t/>
             </a:r>
           </a:p>
           <a:p xmlns:a="http://schemas.openxmlformats.org/drawingml/2006/main">
@@ -1863,7 +4538,17 @@
           </a:p>
           <a:p xmlns:a="http://schemas.openxmlformats.org/drawingml/2006/main">
             <a:r>
-              <a:t>- 本页仅使用课程内部规则与教学材料。</a:t>
+              <a:t/>
+            </a:r>
+          </a:p>
+          <a:p xmlns:a="http://schemas.openxmlformats.org/drawingml/2006/main">
+            <a:r>
+              <a:t>- 本课 handout.md 与 slides.md</a:t>
+            </a:r>
+          </a:p>
+          <a:p xmlns:a="http://schemas.openxmlformats.org/drawingml/2006/main">
+            <a:r>
+              <a:t/>
             </a:r>
           </a:p>
           <a:p xmlns:a="http://schemas.openxmlformats.org/drawingml/2006/main">
@@ -1938,7 +4623,132 @@
           <a:lstStyle xmlns:a="http://schemas.openxmlformats.org/drawingml/2006/main"/>
           <a:p xmlns:a="http://schemas.openxmlformats.org/drawingml/2006/main">
             <a:r>
-              <a:t>页面标题：检索式可被他人复盘</a:t>
+              <a:t>页面：P07 检索式可被他人复盘</a:t>
+            </a:r>
+          </a:p>
+          <a:p xmlns:a="http://schemas.openxmlformats.org/drawingml/2006/main">
+            <a:r>
+              <a:t/>
+            </a:r>
+          </a:p>
+          <a:p xmlns:a="http://schemas.openxmlformats.org/drawingml/2006/main">
+            <a:r>
+              <a:t>讲义位置：本课讲义；见逐页母稿映射表</a:t>
+            </a:r>
+          </a:p>
+          <a:p xmlns:a="http://schemas.openxmlformats.org/drawingml/2006/main">
+            <a:r>
+              <a:t/>
+            </a:r>
+          </a:p>
+          <a:p xmlns:a="http://schemas.openxmlformats.org/drawingml/2006/main">
+            <a:r>
+              <a:t>屏显核对：</a:t>
+            </a:r>
+          </a:p>
+          <a:p xmlns:a="http://schemas.openxmlformats.org/drawingml/2006/main">
+            <a:r>
+              <a:t>```text</a:t>
+            </a:r>
+          </a:p>
+          <a:p xmlns:a="http://schemas.openxmlformats.org/drawingml/2006/main">
+            <a:r>
+              <a:t>("reading card" OR "reading template" OR "structured reading")</a:t>
+            </a:r>
+          </a:p>
+          <a:p xmlns:a="http://schemas.openxmlformats.org/drawingml/2006/main">
+            <a:r>
+              <a:t>AND ("AI summary" OR "LLM summary" OR "AI-generated abstract")</a:t>
+            </a:r>
+          </a:p>
+          <a:p xmlns:a="http://schemas.openxmlformats.org/drawingml/2006/main">
+            <a:r>
+              <a:t>AND ("limitation" OR "scope" OR "boundary")</a:t>
+            </a:r>
+          </a:p>
+          <a:p xmlns:a="http://schemas.openxmlformats.org/drawingml/2006/main">
+            <a:r>
+              <a:t>```</a:t>
+            </a:r>
+          </a:p>
+          <a:p xmlns:a="http://schemas.openxmlformats.org/drawingml/2006/main">
+            <a:r>
+              <a:t/>
+            </a:r>
+          </a:p>
+          <a:p xmlns:a="http://schemas.openxmlformats.org/drawingml/2006/main">
+            <a:r>
+              <a:t>元素：布尔算子｜字段限定｜截断通配｜短语｜时间类型限定</a:t>
+            </a:r>
+          </a:p>
+          <a:p xmlns:a="http://schemas.openxmlformats.org/drawingml/2006/main">
+            <a:r>
+              <a:t/>
+            </a:r>
+          </a:p>
+          <a:p xmlns:a="http://schemas.openxmlformats.org/drawingml/2006/main">
+            <a:r>
+              <a:t>检索记录至少：库｜式｜日期｜命中数｜纳入排除｜筛选数</a:t>
+            </a:r>
+          </a:p>
+          <a:p xmlns:a="http://schemas.openxmlformats.org/drawingml/2006/main">
+            <a:r>
+              <a:t/>
+            </a:r>
+          </a:p>
+          <a:p xmlns:a="http://schemas.openxmlformats.org/drawingml/2006/main">
+            <a:r>
+              <a:t>教师讲述：</a:t>
+            </a:r>
+          </a:p>
+          <a:p xmlns:a="http://schemas.openxmlformats.org/drawingml/2006/main">
+            <a:r>
+              <a:t>检索式不是"搜索框里打几个词"，而是可被他人复盘的查询串。检索记录是后续同伴互查和第 6 课问题门检查的依据。检索式应记录下来，使他人可以重现你怎样得到当前结果。</a:t>
+            </a:r>
+          </a:p>
+          <a:p xmlns:a="http://schemas.openxmlformats.org/drawingml/2006/main">
+            <a:r>
+              <a:t/>
+            </a:r>
+          </a:p>
+          <a:p xmlns:a="http://schemas.openxmlformats.org/drawingml/2006/main">
+            <a:r>
+              <a:t>学生动作：</a:t>
+            </a:r>
+          </a:p>
+          <a:p xmlns:a="http://schemas.openxmlformats.org/drawingml/2006/main">
+            <a:r>
+              <a:t>让学生用自己的关键词草拟一条检索式，并标记用到的布尔算子。</a:t>
+            </a:r>
+          </a:p>
+          <a:p xmlns:a="http://schemas.openxmlformats.org/drawingml/2006/main">
+            <a:r>
+              <a:t/>
+            </a:r>
+          </a:p>
+          <a:p xmlns:a="http://schemas.openxmlformats.org/drawingml/2006/main">
+            <a:r>
+              <a:t>来源与边界：</a:t>
+            </a:r>
+          </a:p>
+          <a:p xmlns:a="http://schemas.openxmlformats.org/drawingml/2006/main">
+            <a:r>
+              <a:t>检索式为课程自编示例；可参照 Kitchenham &amp; Charters SLR guidelines 的 search strategy 部分（[reading-list.md](../../course/reading-list.md) 第 3 课）。</a:t>
+            </a:r>
+          </a:p>
+          <a:p xmlns:a="http://schemas.openxmlformats.org/drawingml/2006/main">
+            <a:r>
+              <a:t/>
+            </a:r>
+          </a:p>
+          <a:p xmlns:a="http://schemas.openxmlformats.org/drawingml/2006/main">
+            <a:r>
+              <a:t>---</a:t>
+            </a:r>
+          </a:p>
+          <a:p xmlns:a="http://schemas.openxmlformats.org/drawingml/2006/main">
+            <a:r>
+              <a:t/>
             </a:r>
           </a:p>
           <a:p xmlns:a="http://schemas.openxmlformats.org/drawingml/2006/main">
@@ -1948,7 +4758,17 @@
           </a:p>
           <a:p xmlns:a="http://schemas.openxmlformats.org/drawingml/2006/main">
             <a:r>
-              <a:t>- 本页仅使用课程内部规则与教学材料。</a:t>
+              <a:t/>
+            </a:r>
+          </a:p>
+          <a:p xmlns:a="http://schemas.openxmlformats.org/drawingml/2006/main">
+            <a:r>
+              <a:t>- 本课 handout.md 与 slides.md</a:t>
+            </a:r>
+          </a:p>
+          <a:p xmlns:a="http://schemas.openxmlformats.org/drawingml/2006/main">
+            <a:r>
+              <a:t/>
             </a:r>
           </a:p>
           <a:p xmlns:a="http://schemas.openxmlformats.org/drawingml/2006/main">
@@ -2023,7 +4843,127 @@
           <a:lstStyle xmlns:a="http://schemas.openxmlformats.org/drawingml/2006/main"/>
           <a:p xmlns:a="http://schemas.openxmlformats.org/drawingml/2006/main">
             <a:r>
-              <a:t>页面标题：纳入与排除条件检索前先写</a:t>
+              <a:t>页面：P08 纳入与排除条件检索前先写</a:t>
+            </a:r>
+          </a:p>
+          <a:p xmlns:a="http://schemas.openxmlformats.org/drawingml/2006/main">
+            <a:r>
+              <a:t/>
+            </a:r>
+          </a:p>
+          <a:p xmlns:a="http://schemas.openxmlformats.org/drawingml/2006/main">
+            <a:r>
+              <a:t>讲义位置：本课讲义；见逐页母稿映射表</a:t>
+            </a:r>
+          </a:p>
+          <a:p xmlns:a="http://schemas.openxmlformats.org/drawingml/2006/main">
+            <a:r>
+              <a:t/>
+            </a:r>
+          </a:p>
+          <a:p xmlns:a="http://schemas.openxmlformats.org/drawingml/2006/main">
+            <a:r>
+              <a:t>屏显核对：</a:t>
+            </a:r>
+          </a:p>
+          <a:p xmlns:a="http://schemas.openxmlformats.org/drawingml/2006/main">
+            <a:r>
+              <a:t>纳入/排除维度：</a:t>
+            </a:r>
+          </a:p>
+          <a:p xmlns:a="http://schemas.openxmlformats.org/drawingml/2006/main">
+            <a:r>
+              <a:t>- 时间范围</a:t>
+            </a:r>
+          </a:p>
+          <a:p xmlns:a="http://schemas.openxmlformats.org/drawingml/2006/main">
+            <a:r>
+              <a:t>- 文献类型（同行评议/预印本/综述）</a:t>
+            </a:r>
+          </a:p>
+          <a:p xmlns:a="http://schemas.openxmlformats.org/drawingml/2006/main">
+            <a:r>
+              <a:t>- 语言（应说明理由，避免偏倚）</a:t>
+            </a:r>
+          </a:p>
+          <a:p xmlns:a="http://schemas.openxmlformats.org/drawingml/2006/main">
+            <a:r>
+              <a:t>- 研究类型（实证/方法/案例/综述）</a:t>
+            </a:r>
+          </a:p>
+          <a:p xmlns:a="http://schemas.openxmlformats.org/drawingml/2006/main">
+            <a:r>
+              <a:t>- 相关性（与当前问题或拟用主张的对应程度）</a:t>
+            </a:r>
+          </a:p>
+          <a:p xmlns:a="http://schemas.openxmlformats.org/drawingml/2006/main">
+            <a:r>
+              <a:t/>
+            </a:r>
+          </a:p>
+          <a:p xmlns:a="http://schemas.openxmlformats.org/drawingml/2006/main">
+            <a:r>
+              <a:t>排除一项论文 → 记录理由</a:t>
+            </a:r>
+          </a:p>
+          <a:p xmlns:a="http://schemas.openxmlformats.org/drawingml/2006/main">
+            <a:r>
+              <a:t/>
+            </a:r>
+          </a:p>
+          <a:p xmlns:a="http://schemas.openxmlformats.org/drawingml/2006/main">
+            <a:r>
+              <a:t>教师讲述：</a:t>
+            </a:r>
+          </a:p>
+          <a:p xmlns:a="http://schemas.openxmlformats.org/drawingml/2006/main">
+            <a:r>
+              <a:t>纳入排除不是事后补写。检索前先写第一版，检索中根据结果调整。排除一项论文时记录理由，使后续复盘和同伴互查可以判断筛选是否公平。</a:t>
+            </a:r>
+          </a:p>
+          <a:p xmlns:a="http://schemas.openxmlformats.org/drawingml/2006/main">
+            <a:r>
+              <a:t/>
+            </a:r>
+          </a:p>
+          <a:p xmlns:a="http://schemas.openxmlformats.org/drawingml/2006/main">
+            <a:r>
+              <a:t>学生动作：</a:t>
+            </a:r>
+          </a:p>
+          <a:p xmlns:a="http://schemas.openxmlformats.org/drawingml/2006/main">
+            <a:r>
+              <a:t>请学生说出一条自己可能用到的排除条件，并说明理由。</a:t>
+            </a:r>
+          </a:p>
+          <a:p xmlns:a="http://schemas.openxmlformats.org/drawingml/2006/main">
+            <a:r>
+              <a:t/>
+            </a:r>
+          </a:p>
+          <a:p xmlns:a="http://schemas.openxmlformats.org/drawingml/2006/main">
+            <a:r>
+              <a:t>来源与边界：</a:t>
+            </a:r>
+          </a:p>
+          <a:p xmlns:a="http://schemas.openxmlformats.org/drawingml/2006/main">
+            <a:r>
+              <a:t>Kitchenham &amp; Charters SLR guidelines 的 study selection 部分；PRISMA 2020 flow diagram 逻辑。</a:t>
+            </a:r>
+          </a:p>
+          <a:p xmlns:a="http://schemas.openxmlformats.org/drawingml/2006/main">
+            <a:r>
+              <a:t/>
+            </a:r>
+          </a:p>
+          <a:p xmlns:a="http://schemas.openxmlformats.org/drawingml/2006/main">
+            <a:r>
+              <a:t>---</a:t>
+            </a:r>
+          </a:p>
+          <a:p xmlns:a="http://schemas.openxmlformats.org/drawingml/2006/main">
+            <a:r>
+              <a:t/>
             </a:r>
           </a:p>
           <a:p xmlns:a="http://schemas.openxmlformats.org/drawingml/2006/main">
@@ -2033,7 +4973,17 @@
           </a:p>
           <a:p xmlns:a="http://schemas.openxmlformats.org/drawingml/2006/main">
             <a:r>
-              <a:t>- 本页仅使用课程内部规则与教学材料。</a:t>
+              <a:t/>
+            </a:r>
+          </a:p>
+          <a:p xmlns:a="http://schemas.openxmlformats.org/drawingml/2006/main">
+            <a:r>
+              <a:t>- 本课 handout.md 与 slides.md</a:t>
+            </a:r>
+          </a:p>
+          <a:p xmlns:a="http://schemas.openxmlformats.org/drawingml/2006/main">
+            <a:r>
+              <a:t/>
             </a:r>
           </a:p>
           <a:p xmlns:a="http://schemas.openxmlformats.org/drawingml/2006/main">
@@ -2108,7 +5058,127 @@
           <a:lstStyle xmlns:a="http://schemas.openxmlformats.org/drawingml/2006/main"/>
           <a:p xmlns:a="http://schemas.openxmlformats.org/drawingml/2006/main">
             <a:r>
-              <a:t>页面标题：证据角色：主证据</a:t>
+              <a:t>页面：P09 证据角色：主证据</a:t>
+            </a:r>
+          </a:p>
+          <a:p xmlns:a="http://schemas.openxmlformats.org/drawingml/2006/main">
+            <a:r>
+              <a:t/>
+            </a:r>
+          </a:p>
+          <a:p xmlns:a="http://schemas.openxmlformats.org/drawingml/2006/main">
+            <a:r>
+              <a:t>讲义位置：本课讲义；见逐页母稿映射表</a:t>
+            </a:r>
+          </a:p>
+          <a:p xmlns:a="http://schemas.openxmlformats.org/drawingml/2006/main">
+            <a:r>
+              <a:t/>
+            </a:r>
+          </a:p>
+          <a:p xmlns:a="http://schemas.openxmlformats.org/drawingml/2006/main">
+            <a:r>
+              <a:t>屏显核对：</a:t>
+            </a:r>
+          </a:p>
+          <a:p xmlns:a="http://schemas.openxmlformats.org/drawingml/2006/main">
+            <a:r>
+              <a:t>主证据</a:t>
+            </a:r>
+          </a:p>
+          <a:p xmlns:a="http://schemas.openxmlformats.org/drawingml/2006/main">
+            <a:r>
+              <a:t>- 在可比条件下直接支持或反驳当前问题或拟用主张</a:t>
+            </a:r>
+          </a:p>
+          <a:p xmlns:a="http://schemas.openxmlformats.org/drawingml/2006/main">
+            <a:r>
+              <a:t>- 角色先作预期标注，精读后可修正</a:t>
+            </a:r>
+          </a:p>
+          <a:p xmlns:a="http://schemas.openxmlformats.org/drawingml/2006/main">
+            <a:r>
+              <a:t/>
+            </a:r>
+          </a:p>
+          <a:p xmlns:a="http://schemas.openxmlformats.org/drawingml/2006/main">
+            <a:r>
+              <a:t>能做：支撑核心主张</a:t>
+            </a:r>
+          </a:p>
+          <a:p xmlns:a="http://schemas.openxmlformats.org/drawingml/2006/main">
+            <a:r>
+              <a:t>不能做：不能单独支撑外推到其他场景</a:t>
+            </a:r>
+          </a:p>
+          <a:p xmlns:a="http://schemas.openxmlformats.org/drawingml/2006/main">
+            <a:r>
+              <a:t/>
+            </a:r>
+          </a:p>
+          <a:p xmlns:a="http://schemas.openxmlformats.org/drawingml/2006/main">
+            <a:r>
+              <a:t>&gt; 一条材料至少标一个角色。</a:t>
+            </a:r>
+          </a:p>
+          <a:p xmlns:a="http://schemas.openxmlformats.org/drawingml/2006/main">
+            <a:r>
+              <a:t/>
+            </a:r>
+          </a:p>
+          <a:p xmlns:a="http://schemas.openxmlformats.org/drawingml/2006/main">
+            <a:r>
+              <a:t>教师讲述：</a:t>
+            </a:r>
+          </a:p>
+          <a:p xmlns:a="http://schemas.openxmlformats.org/drawingml/2006/main">
+            <a:r>
+              <a:t>主证据直接对应当前问题或拟用主张。学生此时不必已有正式机制假设；先标预期角色，第 4-5 课精读和整理后可修正。一条材料可以同时承担多角色，但每个角色都要写明参照的主张。</a:t>
+            </a:r>
+          </a:p>
+          <a:p xmlns:a="http://schemas.openxmlformats.org/drawingml/2006/main">
+            <a:r>
+              <a:t/>
+            </a:r>
+          </a:p>
+          <a:p xmlns:a="http://schemas.openxmlformats.org/drawingml/2006/main">
+            <a:r>
+              <a:t>学生动作：</a:t>
+            </a:r>
+          </a:p>
+          <a:p xmlns:a="http://schemas.openxmlformats.org/drawingml/2006/main">
+            <a:r>
+              <a:t>无。</a:t>
+            </a:r>
+          </a:p>
+          <a:p xmlns:a="http://schemas.openxmlformats.org/drawingml/2006/main">
+            <a:r>
+              <a:t/>
+            </a:r>
+          </a:p>
+          <a:p xmlns:a="http://schemas.openxmlformats.org/drawingml/2006/main">
+            <a:r>
+              <a:t>来源与边界：</a:t>
+            </a:r>
+          </a:p>
+          <a:p xmlns:a="http://schemas.openxmlformats.org/drawingml/2006/main">
+            <a:r>
+              <a:t>讲义 §三 证据角色；[AGENTS.md](../../AGENTS.md) 证据标准。</a:t>
+            </a:r>
+          </a:p>
+          <a:p xmlns:a="http://schemas.openxmlformats.org/drawingml/2006/main">
+            <a:r>
+              <a:t/>
+            </a:r>
+          </a:p>
+          <a:p xmlns:a="http://schemas.openxmlformats.org/drawingml/2006/main">
+            <a:r>
+              <a:t>---</a:t>
+            </a:r>
+          </a:p>
+          <a:p xmlns:a="http://schemas.openxmlformats.org/drawingml/2006/main">
+            <a:r>
+              <a:t/>
             </a:r>
           </a:p>
           <a:p xmlns:a="http://schemas.openxmlformats.org/drawingml/2006/main">
@@ -2118,7 +5188,17 @@
           </a:p>
           <a:p xmlns:a="http://schemas.openxmlformats.org/drawingml/2006/main">
             <a:r>
-              <a:t>- 本页仅使用课程内部规则与教学材料。</a:t>
+              <a:t/>
+            </a:r>
+          </a:p>
+          <a:p xmlns:a="http://schemas.openxmlformats.org/drawingml/2006/main">
+            <a:r>
+              <a:t>- 本课 handout.md 与 slides.md</a:t>
+            </a:r>
+          </a:p>
+          <a:p xmlns:a="http://schemas.openxmlformats.org/drawingml/2006/main">
+            <a:r>
+              <a:t/>
             </a:r>
           </a:p>
           <a:p xmlns:a="http://schemas.openxmlformats.org/drawingml/2006/main">
@@ -2174,7 +5254,7 @@
           <p:nvPr/>
         </p:nvPicPr>
         <p:blipFill>
-          <a:blip xmlns:r="http://schemas.openxmlformats.org/officeDocument/2006/relationships" xmlns:a="http://schemas.openxmlformats.org/drawingml/2006/main" r:embed="R6050a5aad59f45d8">
+          <a:blip xmlns:r="http://schemas.openxmlformats.org/officeDocument/2006/relationships" xmlns:a="http://schemas.openxmlformats.org/drawingml/2006/main" r:embed="Rdf894d67c5ba4fa1">
             <a:duotone>
               <a:prstClr val="black"/>
               <a:schemeClr val="accent1">
@@ -2352,7 +5432,7 @@
           <p:nvPr/>
         </p:nvPicPr>
         <p:blipFill rotWithShape="1">
-          <a:blip xmlns:r="http://schemas.openxmlformats.org/officeDocument/2006/relationships" xmlns:a="http://schemas.openxmlformats.org/drawingml/2006/main" r:embed="R677e72c13fcf4616"/>
+          <a:blip xmlns:r="http://schemas.openxmlformats.org/officeDocument/2006/relationships" xmlns:a="http://schemas.openxmlformats.org/drawingml/2006/main" r:embed="Rc66a46bd16024195"/>
           <a:srcRect xmlns:a="http://schemas.openxmlformats.org/drawingml/2006/main" l="74359" t="0" r="1346" b="0"/>
           <a:stretch xmlns:a="http://schemas.openxmlformats.org/drawingml/2006/main"/>
         </p:blipFill>
@@ -2375,7 +5455,7 @@
           <p:nvPr/>
         </p:nvPicPr>
         <p:blipFill rotWithShape="1">
-          <a:blip xmlns:r="http://schemas.openxmlformats.org/officeDocument/2006/relationships" xmlns:a="http://schemas.openxmlformats.org/drawingml/2006/main" r:embed="Rba20ca9495ba40f6">
+          <a:blip xmlns:r="http://schemas.openxmlformats.org/officeDocument/2006/relationships" xmlns:a="http://schemas.openxmlformats.org/drawingml/2006/main" r:embed="R80e4359a7b894da4">
             <a:alphaModFix amt="35000"/>
           </a:blip>
           <a:srcRect xmlns:a="http://schemas.openxmlformats.org/drawingml/2006/main" l="0" t="9831" r="0" b="36385"/>
@@ -2637,7 +5717,7 @@
           <p:nvPr/>
         </p:nvPicPr>
         <p:blipFill>
-          <a:blip xmlns:r="http://schemas.openxmlformats.org/officeDocument/2006/relationships" xmlns:a="http://schemas.openxmlformats.org/drawingml/2006/main" r:embed="Rb815cb1a35964d5f"/>
+          <a:blip xmlns:r="http://schemas.openxmlformats.org/officeDocument/2006/relationships" xmlns:a="http://schemas.openxmlformats.org/drawingml/2006/main" r:embed="R9aad6ccf377b4aa9"/>
           <a:srcRect xmlns:a="http://schemas.openxmlformats.org/drawingml/2006/main" l="0" t="0" r="54251" b="0"/>
           <a:stretch xmlns:a="http://schemas.openxmlformats.org/drawingml/2006/main"/>
         </p:blipFill>
@@ -2894,7 +5974,7 @@
           <p:nvPr/>
         </p:nvPicPr>
         <p:blipFill rotWithShape="1">
-          <a:blip xmlns:r="http://schemas.openxmlformats.org/officeDocument/2006/relationships" xmlns:a="http://schemas.openxmlformats.org/drawingml/2006/main" r:embed="R15f177861b234111"/>
+          <a:blip xmlns:r="http://schemas.openxmlformats.org/officeDocument/2006/relationships" xmlns:a="http://schemas.openxmlformats.org/drawingml/2006/main" r:embed="R0d8f5dc11d4f4730"/>
           <a:srcRect xmlns:a="http://schemas.openxmlformats.org/drawingml/2006/main" l="0" t="0" r="1346" b="0"/>
           <a:stretch xmlns:a="http://schemas.openxmlformats.org/drawingml/2006/main"/>
         </p:blipFill>
@@ -3077,7 +6157,7 @@
           <p:nvPr/>
         </p:nvPicPr>
         <p:blipFill>
-          <a:blip xmlns:r="http://schemas.openxmlformats.org/officeDocument/2006/relationships" xmlns:a="http://schemas.openxmlformats.org/drawingml/2006/main" r:embed="R36b27aa583de4892"/>
+          <a:blip xmlns:r="http://schemas.openxmlformats.org/officeDocument/2006/relationships" xmlns:a="http://schemas.openxmlformats.org/drawingml/2006/main" r:embed="Rf9fafd2ae04f465c"/>
           <a:stretch xmlns:a="http://schemas.openxmlformats.org/drawingml/2006/main">
             <a:fillRect l="0" t="0" r="0" b="0"/>
           </a:stretch>
@@ -3173,7 +6253,7 @@
           <p:nvPr/>
         </p:nvPicPr>
         <p:blipFill>
-          <a:blip xmlns:r="http://schemas.openxmlformats.org/officeDocument/2006/relationships" xmlns:a="http://schemas.openxmlformats.org/drawingml/2006/main" r:embed="Rb98dd582b7524007">
+          <a:blip xmlns:r="http://schemas.openxmlformats.org/officeDocument/2006/relationships" xmlns:a="http://schemas.openxmlformats.org/drawingml/2006/main" r:embed="R674fce9027be48bc">
             <a:duotone>
               <a:prstClr val="black"/>
               <a:schemeClr val="accent1">
@@ -3340,7 +6420,7 @@
           <p:nvPr/>
         </p:nvPicPr>
         <p:blipFill rotWithShape="1">
-          <a:blip xmlns:r="http://schemas.openxmlformats.org/officeDocument/2006/relationships" xmlns:a="http://schemas.openxmlformats.org/drawingml/2006/main" r:embed="R69c444ca5e374668">
+          <a:blip xmlns:r="http://schemas.openxmlformats.org/officeDocument/2006/relationships" xmlns:a="http://schemas.openxmlformats.org/drawingml/2006/main" r:embed="R3991314be7124573">
             <a:alphaModFix amt="20000"/>
             <a:duotone>
               <a:schemeClr val="accent4">
@@ -3438,10 +6518,10 @@
   </p:cSld>
   <p:clrMap bg1="lt1" tx1="dk1" bg2="lt2" tx2="dk2" accent1="accent1" accent2="accent2" accent3="accent3" accent4="accent4" accent5="accent5" accent6="accent6" hlink="hlink" folHlink="folHlink"/>
   <p:sldLayoutIdLst>
-    <p:sldLayoutId xmlns:r="http://schemas.openxmlformats.org/officeDocument/2006/relationships" id="2147483649" r:id="Rf624793f68154659"/>
-    <p:sldLayoutId xmlns:r="http://schemas.openxmlformats.org/officeDocument/2006/relationships" id="2147483650" r:id="Rc77601512ab644df"/>
-    <p:sldLayoutId xmlns:r="http://schemas.openxmlformats.org/officeDocument/2006/relationships" id="2147483651" r:id="Re08c862b630c4f39"/>
-    <p:sldLayoutId xmlns:r="http://schemas.openxmlformats.org/officeDocument/2006/relationships" id="2147483652" r:id="R86e21cd4c02c4989"/>
+    <p:sldLayoutId xmlns:r="http://schemas.openxmlformats.org/officeDocument/2006/relationships" id="2147483649" r:id="Ra7c510314cf845c5"/>
+    <p:sldLayoutId xmlns:r="http://schemas.openxmlformats.org/officeDocument/2006/relationships" id="2147483650" r:id="R629527c3c99d49c2"/>
+    <p:sldLayoutId xmlns:r="http://schemas.openxmlformats.org/officeDocument/2006/relationships" id="2147483651" r:id="R8f714e9235fb4d0d"/>
+    <p:sldLayoutId xmlns:r="http://schemas.openxmlformats.org/officeDocument/2006/relationships" id="2147483652" r:id="R1e831edb8d654ff7"/>
   </p:sldLayoutIdLst>
   <p:hf hdr="0" ftr="0" dt="0"/>
   <p:txStyles>
@@ -7431,14 +10511,14 @@
       </p:sp>
       <p:pic>
         <p:nvPicPr>
-          <p:cNvPr id="43" name="p14-paper-page"/>
+          <p:cNvPr id="44" name="p14-paper-page"/>
           <p:cNvPicPr>
             <a:picLocks xmlns:a="http://schemas.openxmlformats.org/drawingml/2006/main" noChangeAspect="1"/>
           </p:cNvPicPr>
           <p:nvPr/>
         </p:nvPicPr>
         <p:blipFill>
-          <a:blip xmlns:r="http://schemas.openxmlformats.org/officeDocument/2006/relationships" xmlns:a="http://schemas.openxmlformats.org/drawingml/2006/main" r:embed="R176f0edba29a4bec"/>
+          <a:blip xmlns:r="http://schemas.openxmlformats.org/officeDocument/2006/relationships" xmlns:a="http://schemas.openxmlformats.org/drawingml/2006/main" r:embed="Rc0bb4d3c2c624073"/>
           <a:stretch xmlns:a="http://schemas.openxmlformats.org/drawingml/2006/main"/>
         </p:blipFill>
         <p:spPr>

</xml_diff>